<commit_message>
Populate official 8-slide presentation template strictly in-place
</commit_message>
<xml_diff>
--- a/Hack-AI-Thon_Solution_Presentation_Template.pptx
+++ b/Hack-AI-Thon_Solution_Presentation_Template.pptx
@@ -576,7 +576,7 @@
           <a:lstStyle/>
           <a:p>
             <a:r>
-              <a:t>WHAT TO SAY (50s): “Meetings produce unstructured chaos. But the biggest issue isn't summarizing what happened—it's establishing real accountability. When notes say 'Priya may test, but hasn't confirmed yet' and 'we need a deployment plan soon', a typical LLM tries to be 'helpful' by guessing that Priya is the owner and fabricating a deadline. For EP-01, success means refusing to guess, enforcing strict ownership, isolating undecided architecture forks, and delivering actionable deliverables.”</a:t>
+              <a:t>WHAT TO SAY (50s): “Meetings produce unstructured chaos. But the biggest issue isn't summarizing what happened—it's establishing real accountability. When notes say 'Priya may test, but hasn't confirmed yet', a typical LLM tries to be helpful by guessing Priya is the owner and fabricating a deadline. For EP-01, success means refusing to guess, enforcing strict ownership, isolating undecided architecture forks, and delivering actionable deliverables.”</a:t>
             </a:r>
           </a:p>
         </p:txBody>
@@ -1443,7 +1443,7 @@
         <p:spPr>
           <a:xfrm>
             <a:off x="1939636" y="1842655"/>
-            <a:ext cx="8465128" cy="1723549"/>
+            <a:ext cx="8465128" cy="3108960"/>
           </a:xfrm>
           <a:prstGeom prst="rect">
             <a:avLst/>
@@ -1456,71 +1456,48 @@
           </a:bodyPr>
           <a:lstStyle/>
           <a:p>
-            <a:pPr>
-              <a:defRPr b="1" sz="3600"/>
-            </a:pPr>
-            <a:r>
+            <a:r>
+              <a:rPr sz="4600" b="1">
+                <a:solidFill>
+                  <a:srgbClr val="003B7A"/>
+                </a:solidFill>
+                <a:latin typeface="Aptos Display"/>
+              </a:rPr>
               <a:t>Hack-AI-Thon 2026</a:t>
             </a:r>
-            <a:br/>
-            <a:r>
+          </a:p>
+          <a:p>
+            <a:r>
+              <a:rPr sz="2400">
+                <a:solidFill>
+                  <a:srgbClr val="475569"/>
+                </a:solidFill>
+                <a:latin typeface="Aptos Display"/>
+              </a:rPr>
               <a:t>Solution Presentation</a:t>
             </a:r>
           </a:p>
-          <a:p>
-            <a:endParaRPr lang="en-US" dirty="0"/>
-          </a:p>
-          <a:p>
-            <a:r>
-              <a:rPr lang="en-US" sz="2800" dirty="0"/>
-              <a:t>Solution Presentation</a:t>
-            </a:r>
-          </a:p>
-        </p:txBody>
-      </p:sp>
-      <p:sp>
-        <p:nvSpPr>
-          <p:cNvPr id="3" name="TextBox 2"/>
-          <p:cNvSpPr txBox="1"/>
-          <p:nvPr/>
-        </p:nvSpPr>
-        <p:spPr>
-          <a:xfrm>
-            <a:off x="914400" y="4389120"/>
-            <a:ext cx="10332720" cy="1371600"/>
-          </a:xfrm>
-          <a:prstGeom prst="rect">
-            <a:avLst/>
-          </a:prstGeom>
-          <a:noFill/>
-        </p:spPr>
-        <p:txBody>
-          <a:bodyPr wrap="none">
-            <a:spAutoFit/>
-          </a:bodyPr>
-          <a:lstStyle/>
-          <a:p>
-            <a:pPr>
-              <a:defRPr sz="2200" b="1">
-                <a:solidFill>
-                  <a:srgbClr val="4F46E5"/>
-                </a:solidFill>
-              </a:defRPr>
-            </a:pPr>
-            <a:r>
+          <a:p/>
+          <a:p>
+            <a:r>
+              <a:rPr sz="2000" b="1">
+                <a:solidFill>
+                  <a:srgbClr val="003B7A"/>
+                </a:solidFill>
+                <a:latin typeface="Aptos"/>
+              </a:rPr>
               <a:t>MeetingMind AI — Smart Meeting Action Extractor</a:t>
             </a:r>
           </a:p>
           <a:p>
-            <a:pPr>
-              <a:defRPr sz="1400">
-                <a:solidFill>
-                  <a:srgbClr val="64748B"/>
-                </a:solidFill>
-              </a:defRPr>
-            </a:pPr>
-            <a:r>
-              <a:t>Track 3: Engagement Platforms • Problem EP-01 • Qualcomm Cloud AI Track</a:t>
+            <a:r>
+              <a:rPr sz="1300" b="0">
+                <a:solidFill>
+                  <a:srgbClr val="475569"/>
+                </a:solidFill>
+                <a:latin typeface="Aptos"/>
+              </a:rPr>
+              <a:t>Track 3: Engagement Platforms (EP-01)  •  Qualcomm Cloud AI Track</a:t>
             </a:r>
           </a:p>
         </p:txBody>
@@ -1708,23 +1685,21 @@
           <a:ln/>
         </p:spPr>
         <p:txBody>
-          <a:bodyPr wrap="square" lIns="0" tIns="0" rIns="0" bIns="0" rtlCol="0" anchor="ctr">
+          <a:bodyPr wrap="square" lIns="36576" tIns="36576" rIns="36576" bIns="36576" rtlCol="0" anchor="ctr">
             <a:normAutofit/>
           </a:bodyPr>
           <a:lstStyle/>
           <a:p>
-            <a:pPr marL="0" indent="0">
-              <a:buNone/>
-            </a:pPr>
-            <a:r>
-              <a:rPr sz="1800" b="1">
-                <a:solidFill>
-                  <a:srgbClr val="4F46E5"/>
-                </a:solidFill>
+            <a:pPr algn="l"/>
+            <a:r>
+              <a:rPr sz="2800" b="1">
+                <a:solidFill>
+                  <a:srgbClr val="003B7A"/>
+                </a:solidFill>
+                <a:latin typeface="Aptos"/>
               </a:rPr>
               <a:t>Team MeetingMind</a:t>
             </a:r>
-            <a:endParaRPr lang="en-US" sz="3200" dirty="0"/>
           </a:p>
         </p:txBody>
       </p:sp>
@@ -1841,32 +1816,21 @@
           <a:ln/>
         </p:spPr>
         <p:txBody>
-          <a:bodyPr wrap="square" lIns="254" tIns="254" rIns="254" bIns="254" rtlCol="0" anchor="ctr">
+          <a:bodyPr wrap="square" lIns="36576" tIns="36576" rIns="36576" bIns="36576" rtlCol="0" anchor="ctr">
             <a:normAutofit/>
           </a:bodyPr>
           <a:lstStyle/>
           <a:p>
-            <a:pPr marL="0" indent="0">
-              <a:buNone/>
-            </a:pPr>
-            <a:r>
-              <a:rPr sz="1200">
-                <a:solidFill>
-                  <a:srgbClr val="1E293B"/>
-                </a:solidFill>
-              </a:rPr>
-              <a:t>Infosys IGNITE ENG NEXT 2026</a:t>
-            </a:r>
-            <a:br/>
-            <a:r>
-              <a:rPr sz="1200">
-                <a:solidFill>
-                  <a:srgbClr val="1E293B"/>
-                </a:solidFill>
-              </a:rPr>
-              <a:t>Hack-AI-Thon</a:t>
-            </a:r>
-            <a:endParaRPr lang="en-US" sz="1200" dirty="0"/>
+            <a:pPr algn="l"/>
+            <a:r>
+              <a:rPr sz="1200" b="0">
+                <a:solidFill>
+                  <a:srgbClr val="0F172A"/>
+                </a:solidFill>
+                <a:latin typeface="Aptos"/>
+              </a:rPr>
+              <a:t>Infosys IGNITE ENG NEXT 2026 | Hyderabad</a:t>
+            </a:r>
           </a:p>
         </p:txBody>
       </p:sp>
@@ -1977,47 +1941,21 @@
           <a:ln/>
         </p:spPr>
         <p:txBody>
-          <a:bodyPr wrap="square" lIns="254" tIns="254" rIns="254" bIns="254" rtlCol="0" anchor="ctr">
+          <a:bodyPr wrap="square" lIns="36576" tIns="36576" rIns="36576" bIns="36576" rtlCol="0" anchor="ctr">
             <a:normAutofit/>
           </a:bodyPr>
           <a:lstStyle/>
           <a:p>
-            <a:pPr marL="0" indent="0">
-              <a:buNone/>
-            </a:pPr>
-            <a:r>
-              <a:rPr sz="1100">
-                <a:solidFill>
-                  <a:srgbClr val="1E293B"/>
-                </a:solidFill>
-              </a:rPr>
-              <a:t>Kowshik Ghanta (Full-Stack &amp; AI Systems Lead)</a:t>
-            </a:r>
-            <a:br/>
-            <a:r>
-              <a:rPr sz="1100">
-                <a:solidFill>
-                  <a:srgbClr val="1E293B"/>
-                </a:solidFill>
-              </a:rPr>
-              <a:t>• Team Member 2 (AI Engineer)</a:t>
-            </a:r>
-            <a:br/>
-            <a:r>
-              <a:rPr sz="1100">
-                <a:solidFill>
-                  <a:srgbClr val="1E293B"/>
-                </a:solidFill>
-              </a:rPr>
-              <a:t>• Team Member 3 (Product &amp; QA)</a:t>
-            </a:r>
-            <a:endParaRPr lang="en-US" sz="1200" dirty="0"/>
-          </a:p>
-          <a:p>
-            <a:pPr marL="0" indent="0">
-              <a:buNone/>
-            </a:pPr>
-            <a:endParaRPr lang="en-US" sz="1200" dirty="0"/>
+            <a:pPr algn="l"/>
+            <a:r>
+              <a:rPr sz="1200" b="0">
+                <a:solidFill>
+                  <a:srgbClr val="0F172A"/>
+                </a:solidFill>
+                <a:latin typeface="Aptos"/>
+              </a:rPr>
+              <a:t>Kowshik Ghanta (Lead)  •  Team Member 2  •  Team Member 3</a:t>
+            </a:r>
           </a:p>
         </p:txBody>
       </p:sp>
@@ -2128,32 +2066,21 @@
           <a:ln/>
         </p:spPr>
         <p:txBody>
-          <a:bodyPr wrap="square" lIns="254" tIns="254" rIns="254" bIns="254" rtlCol="0" anchor="ctr">
+          <a:bodyPr wrap="square" lIns="36576" tIns="36576" rIns="36576" bIns="36576" rtlCol="0" anchor="ctr">
             <a:normAutofit/>
           </a:bodyPr>
           <a:lstStyle/>
           <a:p>
-            <a:pPr marL="0" indent="0">
-              <a:buNone/>
-            </a:pPr>
-            <a:r>
-              <a:rPr sz="1100" b="1">
-                <a:solidFill>
-                  <a:srgbClr val="16A34A"/>
-                </a:solidFill>
+            <a:pPr algn="l"/>
+            <a:r>
+              <a:rPr sz="1200" b="1">
+                <a:solidFill>
+                  <a:srgbClr val="003B7A"/>
+                </a:solidFill>
+                <a:latin typeface="Aptos"/>
               </a:rPr>
               <a:t>EP-01: Smart Meeting Action Extractor</a:t>
             </a:r>
-            <a:br/>
-            <a:r>
-              <a:rPr sz="1100" b="1">
-                <a:solidFill>
-                  <a:srgbClr val="16A34A"/>
-                </a:solidFill>
-              </a:rPr>
-              <a:t>Technology Track: Qualcomm Cloud AI Playground (Cirrascale Inference Cloud)</a:t>
-            </a:r>
-            <a:endParaRPr lang="en-US" sz="1200" dirty="0"/>
           </a:p>
         </p:txBody>
       </p:sp>
@@ -2284,23 +2211,21 @@
             <a:ln/>
           </p:spPr>
           <p:txBody>
-            <a:bodyPr wrap="square" lIns="254" tIns="254" rIns="254" bIns="254" rtlCol="0" anchor="ctr">
+            <a:bodyPr wrap="square" lIns="36576" tIns="36576" rIns="36576" bIns="36576" rtlCol="0" anchor="ctr">
               <a:normAutofit/>
             </a:bodyPr>
             <a:lstStyle/>
             <a:p>
-              <a:pPr marL="0" indent="0">
-                <a:buNone/>
-              </a:pPr>
+              <a:pPr algn="l"/>
               <a:r>
-                <a:rPr lang="en-US" sz="1200" i="1" dirty="0">
+                <a:rPr sz="1100" b="1">
                   <a:solidFill>
-                    <a:srgbClr val="7A8793"/>
+                    <a:srgbClr val="003B7A"/>
                   </a:solidFill>
+                  <a:latin typeface="Aptos"/>
                 </a:rPr>
-                <a:t>[UNO Q / AI Playground / Other]</a:t>
+                <a:t>Qualcomm Cloud AI Playground</a:t>
               </a:r>
-              <a:endParaRPr lang="en-US" sz="1200" dirty="0"/>
             </a:p>
           </p:txBody>
         </p:sp>
@@ -2579,41 +2504,123 @@
           <a:ln/>
         </p:spPr>
         <p:txBody>
-          <a:bodyPr wrap="square" lIns="254" tIns="254" rIns="254" bIns="254" rtlCol="0" anchor="ctr">
+          <a:bodyPr wrap="square" lIns="36576" tIns="36576" rIns="36576" bIns="36576" rtlCol="0" anchor="ctr">
             <a:normAutofit/>
           </a:bodyPr>
+          <a:lstStyle/>
+          <a:p>
+            <a:pPr algn="l"/>
+            <a:r>
+              <a:rPr sz="1150" b="0">
+                <a:solidFill>
+                  <a:srgbClr val="0F172A"/>
+                </a:solidFill>
+                <a:latin typeface="Aptos"/>
+              </a:rPr>
+              <a:t>Convert unstructured, messy meeting transcripts into structured decisions, accountable action items, designated owners, unambiguous due dates, and project risks.</a:t>
+            </a:r>
+          </a:p>
+        </p:txBody>
+      </p:sp>
+      <p:sp>
+        <p:nvSpPr>
+          <p:cNvPr id="11" name="Text 9">
+            <a:extLst>
+              <a:ext uri="{FF2B5EF4-FFF2-40B4-BE49-F238E27FC236}">
+                <a16:creationId xmlns:a16="http://schemas.microsoft.com/office/drawing/2014/main" id="{E871A307-2145-F941-36B5-7FB8E48AF6A3}"/>
+              </a:ext>
+            </a:extLst>
+          </p:cNvPr>
+          <p:cNvSpPr/>
+          <p:nvPr/>
+        </p:nvSpPr>
+        <p:spPr>
+          <a:xfrm>
+            <a:off x="7735824" y="1243584"/>
+            <a:ext cx="3803904" cy="164592"/>
+          </a:xfrm>
+          <a:prstGeom prst="rect">
+            <a:avLst/>
+          </a:prstGeom>
+          <a:noFill/>
+          <a:ln/>
+        </p:spPr>
+        <p:txBody>
+          <a:bodyPr wrap="square" lIns="0" tIns="0" rIns="0" bIns="0" rtlCol="0" anchor="ctr"/>
           <a:lstStyle/>
           <a:p>
             <a:pPr marL="0" indent="0">
               <a:buNone/>
             </a:pPr>
             <a:r>
-              <a:rPr sz="1050">
-                <a:solidFill>
-                  <a:srgbClr val="1E293B"/>
-                </a:solidFill>
-              </a:rPr>
-              <a:t>Convert unstructured, messy meeting transcripts into structured decisions, accountable action items, designated owners, unambiguous due dates, and project risks.</a:t>
-            </a:r>
-            <a:endParaRPr lang="en-US" sz="1900" dirty="0"/>
-          </a:p>
-        </p:txBody>
-      </p:sp>
-      <p:sp>
-        <p:nvSpPr>
-          <p:cNvPr id="11" name="Text 9">
-            <a:extLst>
-              <a:ext uri="{FF2B5EF4-FFF2-40B4-BE49-F238E27FC236}">
-                <a16:creationId xmlns:a16="http://schemas.microsoft.com/office/drawing/2014/main" id="{E871A307-2145-F941-36B5-7FB8E48AF6A3}"/>
-              </a:ext>
-            </a:extLst>
-          </p:cNvPr>
-          <p:cNvSpPr/>
-          <p:nvPr/>
-        </p:nvSpPr>
-        <p:spPr>
-          <a:xfrm>
-            <a:off x="7735824" y="1243584"/>
+              <a:rPr lang="en-US" sz="850" b="1" kern="0" spc="70" dirty="0">
+                <a:solidFill>
+                  <a:srgbClr val="F28C28"/>
+                </a:solidFill>
+              </a:rPr>
+              <a:t>WHO IS AFFECTED?</a:t>
+            </a:r>
+            <a:endParaRPr lang="en-US" sz="850" dirty="0"/>
+          </a:p>
+        </p:txBody>
+      </p:sp>
+      <p:sp>
+        <p:nvSpPr>
+          <p:cNvPr id="13" name="Text 10">
+            <a:extLst>
+              <a:ext uri="{FF2B5EF4-FFF2-40B4-BE49-F238E27FC236}">
+                <a16:creationId xmlns:a16="http://schemas.microsoft.com/office/drawing/2014/main" id="{0E1E736B-0A2D-B024-1EB0-12A200895AC2}"/>
+              </a:ext>
+            </a:extLst>
+          </p:cNvPr>
+          <p:cNvSpPr/>
+          <p:nvPr/>
+        </p:nvSpPr>
+        <p:spPr>
+          <a:xfrm>
+            <a:off x="7735824" y="1508760"/>
+            <a:ext cx="3803904" cy="402336"/>
+          </a:xfrm>
+          <a:prstGeom prst="rect">
+            <a:avLst/>
+          </a:prstGeom>
+          <a:noFill/>
+          <a:ln/>
+        </p:spPr>
+        <p:txBody>
+          <a:bodyPr wrap="square" lIns="36576" tIns="36576" rIns="36576" bIns="36576" rtlCol="0" anchor="ctr">
+            <a:normAutofit/>
+          </a:bodyPr>
+          <a:lstStyle/>
+          <a:p>
+            <a:pPr algn="l"/>
+            <a:r>
+              <a:rPr sz="1050" b="0">
+                <a:solidFill>
+                  <a:srgbClr val="0F172A"/>
+                </a:solidFill>
+                <a:latin typeface="Aptos"/>
+              </a:rPr>
+              <a:t>Engineering teams, sprint leads, project managers, scrum masters, and enterprise stakeholders.</a:t>
+            </a:r>
+          </a:p>
+        </p:txBody>
+      </p:sp>
+      <p:sp>
+        <p:nvSpPr>
+          <p:cNvPr id="15" name="Text 12">
+            <a:extLst>
+              <a:ext uri="{FF2B5EF4-FFF2-40B4-BE49-F238E27FC236}">
+                <a16:creationId xmlns:a16="http://schemas.microsoft.com/office/drawing/2014/main" id="{9073DFEC-DABB-CC2B-0BA9-871FADDBD8B2}"/>
+              </a:ext>
+            </a:extLst>
+          </p:cNvPr>
+          <p:cNvSpPr/>
+          <p:nvPr/>
+        </p:nvSpPr>
+        <p:spPr>
+          <a:xfrm>
+            <a:off x="7735824" y="2340864"/>
             <a:ext cx="3803904" cy="164592"/>
           </a:xfrm>
           <a:prstGeom prst="rect">
@@ -2632,10 +2639,10 @@
             <a:r>
               <a:rPr lang="en-US" sz="850" b="1" kern="0" spc="70" dirty="0">
                 <a:solidFill>
-                  <a:srgbClr val="F28C28"/>
-                </a:solidFill>
-              </a:rPr>
-              <a:t>WHO IS AFFECTED?</a:t>
+                  <a:srgbClr val="63A845"/>
+                </a:solidFill>
+              </a:rPr>
+              <a:t>WHY DOES IT MATTER?</a:t>
             </a:r>
             <a:endParaRPr lang="en-US" sz="850" dirty="0"/>
           </a:p>
@@ -2643,19 +2650,19 @@
       </p:sp>
       <p:sp>
         <p:nvSpPr>
-          <p:cNvPr id="13" name="Text 10">
-            <a:extLst>
-              <a:ext uri="{FF2B5EF4-FFF2-40B4-BE49-F238E27FC236}">
-                <a16:creationId xmlns:a16="http://schemas.microsoft.com/office/drawing/2014/main" id="{0E1E736B-0A2D-B024-1EB0-12A200895AC2}"/>
-              </a:ext>
-            </a:extLst>
-          </p:cNvPr>
-          <p:cNvSpPr/>
-          <p:nvPr/>
-        </p:nvSpPr>
-        <p:spPr>
-          <a:xfrm>
-            <a:off x="7735824" y="1508760"/>
+          <p:cNvPr id="17" name="Text 13">
+            <a:extLst>
+              <a:ext uri="{FF2B5EF4-FFF2-40B4-BE49-F238E27FC236}">
+                <a16:creationId xmlns:a16="http://schemas.microsoft.com/office/drawing/2014/main" id="{42C115EF-03A4-A284-3C57-500DFF669693}"/>
+              </a:ext>
+            </a:extLst>
+          </p:cNvPr>
+          <p:cNvSpPr/>
+          <p:nvPr/>
+        </p:nvSpPr>
+        <p:spPr>
+          <a:xfrm>
+            <a:off x="7735824" y="2606040"/>
             <a:ext cx="3803904" cy="402336"/>
           </a:xfrm>
           <a:prstGeom prst="rect">
@@ -2665,42 +2672,124 @@
           <a:ln/>
         </p:spPr>
         <p:txBody>
-          <a:bodyPr wrap="square" lIns="254" tIns="254" rIns="254" bIns="254" rtlCol="0" anchor="ctr">
+          <a:bodyPr wrap="square" lIns="36576" tIns="36576" rIns="36576" bIns="36576" rtlCol="0" anchor="ctr">
             <a:normAutofit/>
           </a:bodyPr>
+          <a:lstStyle/>
+          <a:p>
+            <a:pPr algn="l"/>
+            <a:r>
+              <a:rPr sz="950" b="0">
+                <a:solidFill>
+                  <a:srgbClr val="0F172A"/>
+                </a:solidFill>
+                <a:latin typeface="Aptos"/>
+              </a:rPr>
+              <a:t>30%+ of employee time is spent in meetings. Up to 40% of deliverables are delayed or lost because meeting notes lack explicit owners, timelines are vague ('soon'), or casual proposals are mistaken for agreements.</a:t>
+            </a:r>
+          </a:p>
+        </p:txBody>
+      </p:sp>
+      <p:sp>
+        <p:nvSpPr>
+          <p:cNvPr id="19" name="Text 15">
+            <a:extLst>
+              <a:ext uri="{FF2B5EF4-FFF2-40B4-BE49-F238E27FC236}">
+                <a16:creationId xmlns:a16="http://schemas.microsoft.com/office/drawing/2014/main" id="{6F43253D-9704-E340-ABBE-3C6F52C216CD}"/>
+              </a:ext>
+            </a:extLst>
+          </p:cNvPr>
+          <p:cNvSpPr/>
+          <p:nvPr/>
+        </p:nvSpPr>
+        <p:spPr>
+          <a:xfrm>
+            <a:off x="713232" y="2706624"/>
+            <a:ext cx="2889504" cy="164592"/>
+          </a:xfrm>
+          <a:prstGeom prst="rect">
+            <a:avLst/>
+          </a:prstGeom>
+          <a:noFill/>
+          <a:ln/>
+        </p:spPr>
+        <p:txBody>
+          <a:bodyPr wrap="square" lIns="0" tIns="0" rIns="0" bIns="0" rtlCol="0" anchor="ctr"/>
           <a:lstStyle/>
           <a:p>
             <a:pPr marL="0" indent="0">
               <a:buNone/>
             </a:pPr>
             <a:r>
-              <a:rPr sz="1050">
-                <a:solidFill>
-                  <a:srgbClr val="1E293B"/>
-                </a:solidFill>
-              </a:rPr>
-              <a:t>Engineering teams, sprint leads, project managers, scrum masters, and enterprise stakeholders.</a:t>
-            </a:r>
-            <a:endParaRPr lang="en-US" sz="1200" dirty="0"/>
-          </a:p>
-        </p:txBody>
-      </p:sp>
-      <p:sp>
-        <p:nvSpPr>
-          <p:cNvPr id="15" name="Text 12">
-            <a:extLst>
-              <a:ext uri="{FF2B5EF4-FFF2-40B4-BE49-F238E27FC236}">
-                <a16:creationId xmlns:a16="http://schemas.microsoft.com/office/drawing/2014/main" id="{9073DFEC-DABB-CC2B-0BA9-871FADDBD8B2}"/>
-              </a:ext>
-            </a:extLst>
-          </p:cNvPr>
-          <p:cNvSpPr/>
-          <p:nvPr/>
-        </p:nvSpPr>
-        <p:spPr>
-          <a:xfrm>
-            <a:off x="7735824" y="2340864"/>
-            <a:ext cx="3803904" cy="164592"/>
+              <a:rPr lang="en-US" sz="850" b="1" kern="0" spc="70" dirty="0">
+                <a:solidFill>
+                  <a:srgbClr val="007CC3"/>
+                </a:solidFill>
+              </a:rPr>
+              <a:t>CURRENT GAP / PAIN POINT</a:t>
+            </a:r>
+            <a:endParaRPr lang="en-US" sz="850" dirty="0"/>
+          </a:p>
+        </p:txBody>
+      </p:sp>
+      <p:sp>
+        <p:nvSpPr>
+          <p:cNvPr id="21" name="Text 16">
+            <a:extLst>
+              <a:ext uri="{FF2B5EF4-FFF2-40B4-BE49-F238E27FC236}">
+                <a16:creationId xmlns:a16="http://schemas.microsoft.com/office/drawing/2014/main" id="{4B3CD632-0098-5E4B-5432-77CD2893CAF3}"/>
+              </a:ext>
+            </a:extLst>
+          </p:cNvPr>
+          <p:cNvSpPr/>
+          <p:nvPr/>
+        </p:nvSpPr>
+        <p:spPr>
+          <a:xfrm>
+            <a:off x="713232" y="2971800"/>
+            <a:ext cx="2889504" cy="832104"/>
+          </a:xfrm>
+          <a:prstGeom prst="rect">
+            <a:avLst/>
+          </a:prstGeom>
+          <a:noFill/>
+          <a:ln/>
+        </p:spPr>
+        <p:txBody>
+          <a:bodyPr wrap="square" lIns="36576" tIns="36576" rIns="36576" bIns="36576" rtlCol="0" anchor="ctr">
+            <a:normAutofit/>
+          </a:bodyPr>
+          <a:lstStyle/>
+          <a:p>
+            <a:pPr algn="l"/>
+            <a:r>
+              <a:rPr sz="950" b="0">
+                <a:solidFill>
+                  <a:srgbClr val="0F172A"/>
+                </a:solidFill>
+                <a:latin typeface="Aptos"/>
+              </a:rPr>
+              <a:t>Existing AI tools provide passive narrative summaries. When forced to extract tasks, standard LLMs hallucinate owners who never volunteered, fabricate calendar dates, and smooth over unconfirmed commitments.</a:t>
+            </a:r>
+          </a:p>
+        </p:txBody>
+      </p:sp>
+      <p:sp>
+        <p:nvSpPr>
+          <p:cNvPr id="23" name="Text 18">
+            <a:extLst>
+              <a:ext uri="{FF2B5EF4-FFF2-40B4-BE49-F238E27FC236}">
+                <a16:creationId xmlns:a16="http://schemas.microsoft.com/office/drawing/2014/main" id="{05F37750-2660-1AD0-F71B-75255FDEFAB9}"/>
+              </a:ext>
+            </a:extLst>
+          </p:cNvPr>
+          <p:cNvSpPr/>
+          <p:nvPr/>
+        </p:nvSpPr>
+        <p:spPr>
+          <a:xfrm>
+            <a:off x="4123944" y="2706624"/>
+            <a:ext cx="3072384" cy="164592"/>
           </a:xfrm>
           <a:prstGeom prst="rect">
             <a:avLst/>
@@ -2718,10 +2807,10 @@
             <a:r>
               <a:rPr lang="en-US" sz="850" b="1" kern="0" spc="70" dirty="0">
                 <a:solidFill>
-                  <a:srgbClr val="63A845"/>
-                </a:solidFill>
-              </a:rPr>
-              <a:t>WHY DOES IT MATTER?</a:t>
+                  <a:srgbClr val="F28C28"/>
+                </a:solidFill>
+              </a:rPr>
+              <a:t>EVIDENCE / SCENARIO</a:t>
             </a:r>
             <a:endParaRPr lang="en-US" sz="850" dirty="0"/>
           </a:p>
@@ -2729,20 +2818,20 @@
       </p:sp>
       <p:sp>
         <p:nvSpPr>
-          <p:cNvPr id="17" name="Text 13">
-            <a:extLst>
-              <a:ext uri="{FF2B5EF4-FFF2-40B4-BE49-F238E27FC236}">
-                <a16:creationId xmlns:a16="http://schemas.microsoft.com/office/drawing/2014/main" id="{42C115EF-03A4-A284-3C57-500DFF669693}"/>
-              </a:ext>
-            </a:extLst>
-          </p:cNvPr>
-          <p:cNvSpPr/>
-          <p:nvPr/>
-        </p:nvSpPr>
-        <p:spPr>
-          <a:xfrm>
-            <a:off x="7735824" y="2606040"/>
-            <a:ext cx="3803904" cy="402336"/>
+          <p:cNvPr id="25" name="Text 19">
+            <a:extLst>
+              <a:ext uri="{FF2B5EF4-FFF2-40B4-BE49-F238E27FC236}">
+                <a16:creationId xmlns:a16="http://schemas.microsoft.com/office/drawing/2014/main" id="{824B9B85-9810-1D16-1FED-578C00F4DF52}"/>
+              </a:ext>
+            </a:extLst>
+          </p:cNvPr>
+          <p:cNvSpPr/>
+          <p:nvPr/>
+        </p:nvSpPr>
+        <p:spPr>
+          <a:xfrm>
+            <a:off x="4123944" y="2971800"/>
+            <a:ext cx="3072384" cy="832104"/>
           </a:xfrm>
           <a:prstGeom prst="rect">
             <a:avLst/>
@@ -2751,42 +2840,82 @@
           <a:ln/>
         </p:spPr>
         <p:txBody>
-          <a:bodyPr wrap="square" lIns="254" tIns="254" rIns="254" bIns="254" rtlCol="0" anchor="ctr">
+          <a:bodyPr wrap="square" lIns="36576" tIns="36576" rIns="36576" bIns="36576" rtlCol="0" anchor="ctr">
             <a:normAutofit/>
           </a:bodyPr>
+          <a:lstStyle/>
+          <a:p>
+            <a:pPr algn="l"/>
+            <a:r>
+              <a:rPr sz="950" b="0">
+                <a:solidFill>
+                  <a:srgbClr val="0F172A"/>
+                </a:solidFill>
+                <a:latin typeface="Aptos"/>
+              </a:rPr>
+              <a:t>Real transcript: 'Priya may handle testing, but hasn't confirmed yet. Deployment plan needed soon.' Naive LLMs assign Priya as confirmed owner and invent a date, creating hidden project risk.</a:t>
+            </a:r>
+          </a:p>
+        </p:txBody>
+      </p:sp>
+      <p:sp>
+        <p:nvSpPr>
+          <p:cNvPr id="27" name="Text 21">
+            <a:extLst>
+              <a:ext uri="{FF2B5EF4-FFF2-40B4-BE49-F238E27FC236}">
+                <a16:creationId xmlns:a16="http://schemas.microsoft.com/office/drawing/2014/main" id="{C355BF79-944B-C7CD-13BE-B68144B0EC3D}"/>
+              </a:ext>
+            </a:extLst>
+          </p:cNvPr>
+          <p:cNvSpPr/>
+          <p:nvPr/>
+        </p:nvSpPr>
+        <p:spPr>
+          <a:xfrm>
+            <a:off x="7735824" y="3438144"/>
+            <a:ext cx="3803904" cy="164592"/>
+          </a:xfrm>
+          <a:prstGeom prst="rect">
+            <a:avLst/>
+          </a:prstGeom>
+          <a:noFill/>
+          <a:ln/>
+        </p:spPr>
+        <p:txBody>
+          <a:bodyPr wrap="square" lIns="0" tIns="0" rIns="0" bIns="0" rtlCol="0" anchor="ctr"/>
           <a:lstStyle/>
           <a:p>
             <a:pPr marL="0" indent="0">
               <a:buNone/>
             </a:pPr>
             <a:r>
-              <a:rPr sz="950">
-                <a:solidFill>
-                  <a:srgbClr val="1E293B"/>
-                </a:solidFill>
-              </a:rPr>
-              <a:t>30%+ of employee time is spent in meetings. Up to 40% of deliverables are delayed or lost because meeting notes lack explicit owners, timelines are ambiguous ('soon'), or casual proposals are mistaken for agreements.</a:t>
-            </a:r>
-            <a:endParaRPr lang="en-US" sz="1200" dirty="0"/>
-          </a:p>
-        </p:txBody>
-      </p:sp>
-      <p:sp>
-        <p:nvSpPr>
-          <p:cNvPr id="19" name="Text 15">
-            <a:extLst>
-              <a:ext uri="{FF2B5EF4-FFF2-40B4-BE49-F238E27FC236}">
-                <a16:creationId xmlns:a16="http://schemas.microsoft.com/office/drawing/2014/main" id="{6F43253D-9704-E340-ABBE-3C6F52C216CD}"/>
-              </a:ext>
-            </a:extLst>
-          </p:cNvPr>
-          <p:cNvSpPr/>
-          <p:nvPr/>
-        </p:nvSpPr>
-        <p:spPr>
-          <a:xfrm>
-            <a:off x="713232" y="2706624"/>
-            <a:ext cx="2889504" cy="164592"/>
+              <a:rPr lang="en-US" sz="850" b="1" kern="0" spc="70" dirty="0">
+                <a:solidFill>
+                  <a:srgbClr val="5417A8"/>
+                </a:solidFill>
+              </a:rPr>
+              <a:t>SUCCESS DEFINITION</a:t>
+            </a:r>
+            <a:endParaRPr lang="en-US" sz="850" dirty="0"/>
+          </a:p>
+        </p:txBody>
+      </p:sp>
+      <p:sp>
+        <p:nvSpPr>
+          <p:cNvPr id="29" name="Text 22">
+            <a:extLst>
+              <a:ext uri="{FF2B5EF4-FFF2-40B4-BE49-F238E27FC236}">
+                <a16:creationId xmlns:a16="http://schemas.microsoft.com/office/drawing/2014/main" id="{C74A84FE-3AA0-3CCB-062C-D940850ADC68}"/>
+              </a:ext>
+            </a:extLst>
+          </p:cNvPr>
+          <p:cNvSpPr/>
+          <p:nvPr/>
+        </p:nvSpPr>
+        <p:spPr>
+          <a:xfrm>
+            <a:off x="7735824" y="3703320"/>
+            <a:ext cx="3803904" cy="832104"/>
           </a:xfrm>
           <a:prstGeom prst="rect">
             <a:avLst/>
@@ -2795,264 +2924,57 @@
           <a:ln/>
         </p:spPr>
         <p:txBody>
-          <a:bodyPr wrap="square" lIns="0" tIns="0" rIns="0" bIns="0" rtlCol="0" anchor="ctr"/>
-          <a:lstStyle/>
-          <a:p>
-            <a:pPr marL="0" indent="0">
-              <a:buNone/>
-            </a:pPr>
-            <a:r>
-              <a:rPr lang="en-US" sz="850" b="1" kern="0" spc="70" dirty="0">
-                <a:solidFill>
-                  <a:srgbClr val="007CC3"/>
-                </a:solidFill>
-              </a:rPr>
-              <a:t>CURRENT GAP / PAIN POINT</a:t>
-            </a:r>
-            <a:endParaRPr lang="en-US" sz="850" dirty="0"/>
-          </a:p>
-        </p:txBody>
-      </p:sp>
-      <p:sp>
-        <p:nvSpPr>
-          <p:cNvPr id="21" name="Text 16">
-            <a:extLst>
-              <a:ext uri="{FF2B5EF4-FFF2-40B4-BE49-F238E27FC236}">
-                <a16:creationId xmlns:a16="http://schemas.microsoft.com/office/drawing/2014/main" id="{4B3CD632-0098-5E4B-5432-77CD2893CAF3}"/>
-              </a:ext>
-            </a:extLst>
-          </p:cNvPr>
-          <p:cNvSpPr/>
-          <p:nvPr/>
-        </p:nvSpPr>
-        <p:spPr>
-          <a:xfrm>
-            <a:off x="713232" y="2971800"/>
-            <a:ext cx="2889504" cy="832104"/>
-          </a:xfrm>
-          <a:prstGeom prst="rect">
-            <a:avLst/>
-          </a:prstGeom>
-          <a:noFill/>
-          <a:ln/>
-        </p:spPr>
-        <p:txBody>
-          <a:bodyPr wrap="square" lIns="254" tIns="254" rIns="254" bIns="254" rtlCol="0" anchor="ctr">
+          <a:bodyPr wrap="square" lIns="36576" tIns="36576" rIns="36576" bIns="36576" rtlCol="0" anchor="ctr">
             <a:normAutofit/>
           </a:bodyPr>
           <a:lstStyle/>
           <a:p>
-            <a:pPr marL="0" indent="0">
-              <a:buNone/>
-            </a:pPr>
-            <a:r>
-              <a:rPr sz="950">
-                <a:solidFill>
-                  <a:srgbClr val="1E293B"/>
-                </a:solidFill>
-              </a:rPr>
-              <a:t>Existing meeting AI tools provide passive narrative summaries. When forced to extract tasks, standard LLMs hallucinate owners who never volunteered, guess calendar dates, and smooth over unconfirmed commitments.</a:t>
-            </a:r>
-            <a:endParaRPr lang="en-US" sz="1200" dirty="0"/>
-          </a:p>
-        </p:txBody>
-      </p:sp>
-      <p:sp>
-        <p:nvSpPr>
-          <p:cNvPr id="23" name="Text 18">
-            <a:extLst>
-              <a:ext uri="{FF2B5EF4-FFF2-40B4-BE49-F238E27FC236}">
-                <a16:creationId xmlns:a16="http://schemas.microsoft.com/office/drawing/2014/main" id="{05F37750-2660-1AD0-F71B-75255FDEFAB9}"/>
-              </a:ext>
-            </a:extLst>
-          </p:cNvPr>
-          <p:cNvSpPr/>
-          <p:nvPr/>
-        </p:nvSpPr>
-        <p:spPr>
-          <a:xfrm>
-            <a:off x="4123944" y="2706624"/>
-            <a:ext cx="3072384" cy="164592"/>
-          </a:xfrm>
-          <a:prstGeom prst="rect">
-            <a:avLst/>
-          </a:prstGeom>
-          <a:noFill/>
-          <a:ln/>
-        </p:spPr>
-        <p:txBody>
-          <a:bodyPr wrap="square" lIns="0" tIns="0" rIns="0" bIns="0" rtlCol="0" anchor="ctr"/>
-          <a:lstStyle/>
-          <a:p>
-            <a:pPr marL="0" indent="0">
-              <a:buNone/>
-            </a:pPr>
-            <a:r>
-              <a:rPr lang="en-US" sz="850" b="1" kern="0" spc="70" dirty="0">
-                <a:solidFill>
-                  <a:srgbClr val="F28C28"/>
-                </a:solidFill>
-              </a:rPr>
-              <a:t>EVIDENCE / SCENARIO</a:t>
-            </a:r>
-            <a:endParaRPr lang="en-US" sz="850" dirty="0"/>
-          </a:p>
-        </p:txBody>
-      </p:sp>
-      <p:sp>
-        <p:nvSpPr>
-          <p:cNvPr id="25" name="Text 19">
-            <a:extLst>
-              <a:ext uri="{FF2B5EF4-FFF2-40B4-BE49-F238E27FC236}">
-                <a16:creationId xmlns:a16="http://schemas.microsoft.com/office/drawing/2014/main" id="{824B9B85-9810-1D16-1FED-578C00F4DF52}"/>
-              </a:ext>
-            </a:extLst>
-          </p:cNvPr>
-          <p:cNvSpPr/>
-          <p:nvPr/>
-        </p:nvSpPr>
-        <p:spPr>
-          <a:xfrm>
-            <a:off x="4123944" y="2971800"/>
-            <a:ext cx="3072384" cy="832104"/>
-          </a:xfrm>
-          <a:prstGeom prst="rect">
-            <a:avLst/>
-          </a:prstGeom>
-          <a:noFill/>
-          <a:ln/>
-        </p:spPr>
-        <p:txBody>
-          <a:bodyPr wrap="square" lIns="254" tIns="254" rIns="254" bIns="254" rtlCol="0" anchor="ctr">
-            <a:normAutofit/>
-          </a:bodyPr>
-          <a:lstStyle/>
-          <a:p>
-            <a:pPr marL="0" indent="0">
-              <a:buNone/>
-            </a:pPr>
-            <a:r>
-              <a:rPr sz="950">
-                <a:solidFill>
-                  <a:srgbClr val="D97706"/>
-                </a:solidFill>
-              </a:rPr>
-              <a:t>Real transcript: 'Priya may handle testing, but hasn't confirmed yet. Deployment plan needed soon.' Naive LLMs assign Priya as confirmed owner and invent a date, creating hidden project risk.</a:t>
-            </a:r>
-            <a:endParaRPr lang="en-US" sz="1200" dirty="0"/>
-          </a:p>
-        </p:txBody>
-      </p:sp>
-      <p:sp>
-        <p:nvSpPr>
-          <p:cNvPr id="27" name="Text 21">
-            <a:extLst>
-              <a:ext uri="{FF2B5EF4-FFF2-40B4-BE49-F238E27FC236}">
-                <a16:creationId xmlns:a16="http://schemas.microsoft.com/office/drawing/2014/main" id="{C355BF79-944B-C7CD-13BE-B68144B0EC3D}"/>
-              </a:ext>
-            </a:extLst>
-          </p:cNvPr>
-          <p:cNvSpPr/>
-          <p:nvPr/>
-        </p:nvSpPr>
-        <p:spPr>
-          <a:xfrm>
-            <a:off x="7735824" y="3438144"/>
-            <a:ext cx="3803904" cy="164592"/>
-          </a:xfrm>
-          <a:prstGeom prst="rect">
-            <a:avLst/>
-          </a:prstGeom>
-          <a:noFill/>
-          <a:ln/>
-        </p:spPr>
-        <p:txBody>
-          <a:bodyPr wrap="square" lIns="0" tIns="0" rIns="0" bIns="0" rtlCol="0" anchor="ctr"/>
-          <a:lstStyle/>
-          <a:p>
-            <a:pPr marL="0" indent="0">
-              <a:buNone/>
-            </a:pPr>
-            <a:r>
-              <a:rPr lang="en-US" sz="850" b="1" kern="0" spc="70" dirty="0">
-                <a:solidFill>
-                  <a:srgbClr val="5417A8"/>
-                </a:solidFill>
-              </a:rPr>
-              <a:t>SUCCESS DEFINITION</a:t>
-            </a:r>
-            <a:endParaRPr lang="en-US" sz="850" dirty="0"/>
-          </a:p>
-        </p:txBody>
-      </p:sp>
-      <p:sp>
-        <p:nvSpPr>
-          <p:cNvPr id="29" name="Text 22">
-            <a:extLst>
-              <a:ext uri="{FF2B5EF4-FFF2-40B4-BE49-F238E27FC236}">
-                <a16:creationId xmlns:a16="http://schemas.microsoft.com/office/drawing/2014/main" id="{C74A84FE-3AA0-3CCB-062C-D940850ADC68}"/>
-              </a:ext>
-            </a:extLst>
-          </p:cNvPr>
-          <p:cNvSpPr/>
-          <p:nvPr/>
-        </p:nvSpPr>
-        <p:spPr>
-          <a:xfrm>
-            <a:off x="7735824" y="3703320"/>
-            <a:ext cx="3803904" cy="832104"/>
-          </a:xfrm>
-          <a:prstGeom prst="rect">
-            <a:avLst/>
-          </a:prstGeom>
-          <a:noFill/>
-          <a:ln/>
-        </p:spPr>
-        <p:txBody>
-          <a:bodyPr wrap="square" lIns="254" tIns="254" rIns="254" bIns="254" rtlCol="0" anchor="ctr">
-            <a:normAutofit/>
-          </a:bodyPr>
-          <a:lstStyle/>
-          <a:p>
-            <a:pPr marL="0" indent="0">
-              <a:buNone/>
-            </a:pPr>
-            <a:r>
-              <a:rPr sz="950">
-                <a:solidFill>
-                  <a:srgbClr val="16A34A"/>
-                </a:solidFill>
+            <a:pPr algn="l"/>
+            <a:r>
+              <a:rPr sz="950" b="0">
+                <a:solidFill>
+                  <a:srgbClr val="0F172A"/>
+                </a:solidFill>
+                <a:latin typeface="Aptos"/>
               </a:rPr>
               <a:t>1. Verbatim extraction of confirmed tasks.</a:t>
             </a:r>
-            <a:br/>
-            <a:r>
-              <a:rPr sz="950">
-                <a:solidFill>
-                  <a:srgbClr val="16A34A"/>
-                </a:solidFill>
+          </a:p>
+          <a:p>
+            <a:pPr algn="l"/>
+            <a:r>
+              <a:rPr sz="950" b="0">
+                <a:solidFill>
+                  <a:srgbClr val="0F172A"/>
+                </a:solidFill>
+                <a:latin typeface="Aptos"/>
               </a:rPr>
               <a:t>2. Explicit null-handling for missing data (never guessing).</a:t>
             </a:r>
-            <a:br/>
-            <a:r>
-              <a:rPr sz="950">
-                <a:solidFill>
-                  <a:srgbClr val="16A34A"/>
-                </a:solidFill>
+          </a:p>
+          <a:p>
+            <a:pPr algn="l"/>
+            <a:r>
+              <a:rPr sz="950" b="0">
+                <a:solidFill>
+                  <a:srgbClr val="0F172A"/>
+                </a:solidFill>
+                <a:latin typeface="Aptos"/>
               </a:rPr>
               <a:t>3. Deterministic flags with targeted clarification questions.</a:t>
             </a:r>
-            <a:br/>
-            <a:r>
-              <a:rPr sz="950">
-                <a:solidFill>
-                  <a:srgbClr val="16A34A"/>
-                </a:solidFill>
+          </a:p>
+          <a:p>
+            <a:pPr algn="l"/>
+            <a:r>
+              <a:rPr sz="950" b="0">
+                <a:solidFill>
+                  <a:srgbClr val="0F172A"/>
+                </a:solidFill>
+                <a:latin typeface="Aptos"/>
               </a:rPr>
               <a:t>4. RFC-compliant Jira/Asana CSV and JSON export.</a:t>
             </a:r>
-            <a:endParaRPr lang="en-US" sz="1200" dirty="0"/>
           </a:p>
         </p:txBody>
       </p:sp>
@@ -3280,23 +3202,21 @@
           <a:ln/>
         </p:spPr>
         <p:txBody>
-          <a:bodyPr wrap="square" lIns="254" tIns="254" rIns="254" bIns="254" rtlCol="0" anchor="ctr">
+          <a:bodyPr wrap="square" lIns="36576" tIns="36576" rIns="36576" bIns="36576" rtlCol="0" anchor="ctr">
             <a:normAutofit lnSpcReduction="10000"/>
           </a:bodyPr>
           <a:lstStyle/>
           <a:p>
-            <a:pPr marL="0" indent="0">
-              <a:buNone/>
-            </a:pPr>
+            <a:pPr algn="l"/>
             <a:r>
               <a:rPr sz="1100" b="1">
                 <a:solidFill>
-                  <a:srgbClr val="4F46E5"/>
-                </a:solidFill>
+                  <a:srgbClr val="003B7A"/>
+                </a:solidFill>
+                <a:latin typeface="Aptos"/>
               </a:rPr>
               <a:t>Our solution uses Qualcomm Cloud AI and a deterministic Python validation engine to help engineering teams extract accountable action items from messy notes with zero hallucination.</a:t>
             </a:r>
-            <a:endParaRPr lang="en-US" sz="1900" dirty="0"/>
           </a:p>
         </p:txBody>
       </p:sp>
@@ -3488,33 +3408,36 @@
           <a:ln/>
         </p:spPr>
         <p:txBody>
-          <a:bodyPr wrap="square" lIns="381" tIns="381" rIns="381" bIns="381" rtlCol="0" anchor="ctr">
+          <a:bodyPr wrap="square" lIns="36576" tIns="36576" rIns="36576" bIns="36576" rtlCol="0" anchor="ctr">
             <a:normAutofit/>
           </a:bodyPr>
           <a:lstStyle/>
           <a:p>
-            <a:pPr marL="0" indent="0">
-              <a:buNone/>
-            </a:pPr>
-            <a:r>
-              <a:rPr sz="950">
-                <a:solidFill>
-                  <a:srgbClr val="1E293B"/>
-                </a:solidFill>
-              </a:rPr>
-              <a:t>Raw unstructured meeting notes, voice transcripts, or bullet points pasted into the web dashboard (with optional title &amp; date).</a:t>
-            </a:r>
-            <a:br/>
-            <a:br/>
-            <a:r>
-              <a:rPr sz="950">
-                <a:solidFill>
-                  <a:srgbClr val="1E293B"/>
-                </a:solidFill>
-              </a:rPr>
-              <a:t>• 1-Click bundled benchmark notes for immediate evaluation.</a:t>
-            </a:r>
-            <a:endParaRPr lang="en-US" sz="1300" dirty="0"/>
+            <a:pPr algn="l"/>
+            <a:r>
+              <a:rPr sz="950" b="0">
+                <a:solidFill>
+                  <a:srgbClr val="0F172A"/>
+                </a:solidFill>
+                <a:latin typeface="Aptos"/>
+              </a:rPr>
+              <a:t>Raw unstructured meeting notes, voice transcripts, or bullet points pasted into the web dashboard.</a:t>
+            </a:r>
+          </a:p>
+          <a:p>
+            <a:pPr algn="l"/>
+          </a:p>
+          <a:p>
+            <a:pPr algn="l"/>
+            <a:r>
+              <a:rPr sz="950" b="0">
+                <a:solidFill>
+                  <a:srgbClr val="0F172A"/>
+                </a:solidFill>
+                <a:latin typeface="Aptos"/>
+              </a:rPr>
+              <a:t>• Includes 1-Click bundled benchmark notes for immediate evaluation.</a:t>
+            </a:r>
           </a:p>
         </p:txBody>
       </p:sp>
@@ -3748,41 +3671,45 @@
           <a:ln/>
         </p:spPr>
         <p:txBody>
-          <a:bodyPr wrap="square" lIns="381" tIns="381" rIns="381" bIns="381" rtlCol="0" anchor="ctr">
+          <a:bodyPr wrap="square" lIns="36576" tIns="36576" rIns="36576" bIns="36576" rtlCol="0" anchor="ctr">
             <a:normAutofit/>
           </a:bodyPr>
           <a:lstStyle/>
           <a:p>
-            <a:pPr marL="0" indent="0">
-              <a:buNone/>
-            </a:pPr>
-            <a:r>
-              <a:rPr sz="950">
-                <a:solidFill>
-                  <a:srgbClr val="1E293B"/>
-                </a:solidFill>
+            <a:pPr algn="l"/>
+            <a:r>
+              <a:rPr sz="950" b="0">
+                <a:solidFill>
+                  <a:srgbClr val="0F172A"/>
+                </a:solidFill>
+                <a:latin typeface="Aptos"/>
               </a:rPr>
               <a:t>Dual-Layer Processing:</a:t>
             </a:r>
-            <a:br/>
-            <a:r>
-              <a:rPr sz="950">
-                <a:solidFill>
-                  <a:srgbClr val="1E293B"/>
-                </a:solidFill>
+          </a:p>
+          <a:p>
+            <a:pPr algn="l"/>
+            <a:r>
+              <a:rPr sz="950" b="0">
+                <a:solidFill>
+                  <a:srgbClr val="0F172A"/>
+                </a:solidFill>
+                <a:latin typeface="Aptos"/>
               </a:rPr>
               <a:t>1. Qualcomm Cloud AI extracts entities backed by verbatim evidence quotes.</a:t>
             </a:r>
-            <a:br/>
-            <a:r>
-              <a:rPr sz="950">
-                <a:solidFill>
-                  <a:srgbClr val="1E293B"/>
-                </a:solidFill>
+          </a:p>
+          <a:p>
+            <a:pPr algn="l"/>
+            <a:r>
+              <a:rPr sz="950" b="0">
+                <a:solidFill>
+                  <a:srgbClr val="0F172A"/>
+                </a:solidFill>
+                <a:latin typeface="Aptos"/>
               </a:rPr>
               <a:t>2. Deterministic Python engine audits missing owners, deadlines, tentative flags, and vague words.</a:t>
             </a:r>
-            <a:endParaRPr lang="en-US" sz="1300" dirty="0"/>
           </a:p>
         </p:txBody>
       </p:sp>
@@ -4016,23 +3943,21 @@
           <a:ln/>
         </p:spPr>
         <p:txBody>
-          <a:bodyPr wrap="square" lIns="381" tIns="381" rIns="381" bIns="381" rtlCol="0" anchor="ctr">
+          <a:bodyPr wrap="square" lIns="36576" tIns="36576" rIns="36576" bIns="36576" rtlCol="0" anchor="ctr">
             <a:normAutofit/>
           </a:bodyPr>
           <a:lstStyle/>
           <a:p>
-            <a:pPr marL="0" indent="0">
-              <a:buNone/>
-            </a:pPr>
-            <a:r>
-              <a:rPr sz="950">
-                <a:solidFill>
-                  <a:srgbClr val="1E293B"/>
-                </a:solidFill>
+            <a:pPr algn="l"/>
+            <a:r>
+              <a:rPr sz="950" b="0">
+                <a:solidFill>
+                  <a:srgbClr val="0F172A"/>
+                </a:solidFill>
+                <a:latin typeface="Aptos"/>
               </a:rPr>
               <a:t>Interactive Action Table with in-session triage, Decisions vs Proposals breakdown, targeted Clarification Questions, and 1-click Jira/Asana CSV &amp; JSON exports.</a:t>
             </a:r>
-            <a:endParaRPr lang="en-US" sz="1300" dirty="0"/>
           </a:p>
         </p:txBody>
       </p:sp>
@@ -4091,8 +4016,8 @@
         </p:nvSpPr>
         <p:spPr>
           <a:xfrm>
-            <a:off x="713232" y="4517136"/>
-            <a:ext cx="10826496" cy="164592"/>
+            <a:off x="713232" y="4462272"/>
+            <a:ext cx="10826496" cy="438912"/>
           </a:xfrm>
           <a:prstGeom prst="rect">
             <a:avLst/>
@@ -4101,21 +4026,19 @@
           <a:ln/>
         </p:spPr>
         <p:txBody>
-          <a:bodyPr wrap="square" lIns="0" tIns="0" rIns="0" bIns="0" rtlCol="0" anchor="ctr"/>
-          <a:lstStyle/>
-          <a:p>
-            <a:pPr marL="0" indent="0">
-              <a:buNone/>
-            </a:pPr>
+          <a:bodyPr wrap="square" lIns="36576" tIns="36576" rIns="36576" bIns="36576" rtlCol="0" anchor="ctr"/>
+          <a:lstStyle/>
+          <a:p>
+            <a:pPr algn="l"/>
             <a:r>
               <a:rPr sz="1000" b="1">
                 <a:solidFill>
-                  <a:srgbClr val="16A34A"/>
-                </a:solidFill>
-              </a:rPr>
-              <a:t>KEY VALUE / DIFFERENTIATOR: The 'Anti-Hallucination' Accountability Engine — Strictly grounds tasks in verbatim quotes, refuses to invent missing data, and auto-generates targeted clarification questions.</a:t>
-            </a:r>
-            <a:endParaRPr lang="en-US" sz="850" dirty="0"/>
+                  <a:srgbClr val="003B7A"/>
+                </a:solidFill>
+                <a:latin typeface="Aptos"/>
+              </a:rPr>
+              <a:t>KEY VALUE / DIFFERENTIATOR: The Anti-Hallucination Engine — Strictly grounds tasks in verbatim quotes, refuses to invent missing data, and auto-generates targeted clarification questions.</a:t>
+            </a:r>
           </a:p>
         </p:txBody>
       </p:sp>
@@ -4717,23 +4640,21 @@
           <a:ln/>
         </p:spPr>
         <p:txBody>
-          <a:bodyPr wrap="square" lIns="254" tIns="254" rIns="254" bIns="254" rtlCol="0" anchor="ctr">
+          <a:bodyPr wrap="square" lIns="36576" tIns="36576" rIns="36576" bIns="36576" rtlCol="0" anchor="ctr">
             <a:normAutofit/>
           </a:bodyPr>
           <a:lstStyle/>
           <a:p>
-            <a:pPr marL="0" indent="0" algn="ctr">
-              <a:buNone/>
-            </a:pPr>
-            <a:r>
-              <a:rPr sz="900">
-                <a:solidFill>
-                  <a:srgbClr val="1E293B"/>
-                </a:solidFill>
+            <a:pPr algn="l"/>
+            <a:r>
+              <a:rPr sz="900" b="0">
+                <a:solidFill>
+                  <a:srgbClr val="0F172A"/>
+                </a:solidFill>
+                <a:latin typeface="Aptos"/>
               </a:rPr>
               <a:t>Web Browser / Engineering Team / Project Lead accessing Streamlit SaaS Dashboard</a:t>
             </a:r>
-            <a:endParaRPr lang="en-US" sz="1150" dirty="0"/>
           </a:p>
         </p:txBody>
       </p:sp>
@@ -4882,23 +4803,21 @@
           <a:ln/>
         </p:spPr>
         <p:txBody>
-          <a:bodyPr wrap="square" lIns="254" tIns="254" rIns="254" bIns="254" rtlCol="0" anchor="ctr">
+          <a:bodyPr wrap="square" lIns="36576" tIns="36576" rIns="36576" bIns="36576" rtlCol="0" anchor="ctr">
             <a:normAutofit/>
           </a:bodyPr>
           <a:lstStyle/>
           <a:p>
-            <a:pPr marL="0" indent="0" algn="ctr">
-              <a:buNone/>
-            </a:pPr>
-            <a:r>
-              <a:rPr sz="900">
-                <a:solidFill>
-                  <a:srgbClr val="1E293B"/>
-                </a:solidFill>
+            <a:pPr algn="l"/>
+            <a:r>
+              <a:rPr sz="900" b="0">
+                <a:solidFill>
+                  <a:srgbClr val="0F172A"/>
+                </a:solidFill>
+                <a:latin typeface="Aptos"/>
               </a:rPr>
               <a:t>Streamlit UI (v1.42+), Pydantic v2 validation contracts, Session State triage, and Pandas tabular pipeline</a:t>
             </a:r>
-            <a:endParaRPr lang="en-US" sz="1150" dirty="0"/>
           </a:p>
         </p:txBody>
       </p:sp>
@@ -5047,23 +4966,21 @@
           <a:ln/>
         </p:spPr>
         <p:txBody>
-          <a:bodyPr wrap="square" lIns="254" tIns="254" rIns="254" bIns="254" rtlCol="0" anchor="ctr">
+          <a:bodyPr wrap="square" lIns="36576" tIns="36576" rIns="36576" bIns="36576" rtlCol="0" anchor="ctr">
             <a:normAutofit/>
           </a:bodyPr>
           <a:lstStyle/>
           <a:p>
-            <a:pPr marL="0" indent="0" algn="ctr">
-              <a:buNone/>
-            </a:pPr>
-            <a:r>
-              <a:rPr sz="900">
-                <a:solidFill>
-                  <a:srgbClr val="1E293B"/>
-                </a:solidFill>
+            <a:pPr algn="l"/>
+            <a:r>
+              <a:rPr sz="900" b="0">
+                <a:solidFill>
+                  <a:srgbClr val="0F172A"/>
+                </a:solidFill>
+                <a:latin typeface="Aptos"/>
               </a:rPr>
               <a:t>Cirrascale Qualcomm Cloud AI (/apis/v2), DeepSeek-R1-Distill-70B &amp; Llama-3.1-8B, zero-hallucination prompt contract</a:t>
             </a:r>
-            <a:endParaRPr lang="en-US" sz="1150" dirty="0"/>
           </a:p>
         </p:txBody>
       </p:sp>
@@ -5212,23 +5129,21 @@
           <a:ln/>
         </p:spPr>
         <p:txBody>
-          <a:bodyPr wrap="square" lIns="254" tIns="254" rIns="254" bIns="254" rtlCol="0" anchor="ctr">
+          <a:bodyPr wrap="square" lIns="36576" tIns="36576" rIns="36576" bIns="36576" rtlCol="0" anchor="ctr">
             <a:normAutofit/>
           </a:bodyPr>
           <a:lstStyle/>
           <a:p>
-            <a:pPr marL="0" indent="0" algn="ctr">
-              <a:buNone/>
-            </a:pPr>
-            <a:r>
-              <a:rPr sz="900">
-                <a:solidFill>
-                  <a:srgbClr val="1E293B"/>
-                </a:solidFill>
+            <a:pPr algn="l"/>
+            <a:r>
+              <a:rPr sz="900" b="0">
+                <a:solidFill>
+                  <a:srgbClr val="0F172A"/>
+                </a:solidFill>
+                <a:latin typeface="Aptos"/>
               </a:rPr>
               <a:t>Interactive Action Table, Jira/Asana-ready CSV export, schema-validated JSON, and Clarification Alerts</a:t>
             </a:r>
-            <a:endParaRPr lang="en-US" sz="1150" dirty="0"/>
           </a:p>
         </p:txBody>
       </p:sp>
@@ -5339,23 +5254,21 @@
           <a:ln/>
         </p:spPr>
         <p:txBody>
-          <a:bodyPr wrap="square" lIns="254" tIns="254" rIns="254" bIns="254" rtlCol="0" anchor="ctr">
+          <a:bodyPr wrap="square" lIns="36576" tIns="36576" rIns="36576" bIns="36576" rtlCol="0" anchor="ctr">
             <a:normAutofit/>
           </a:bodyPr>
           <a:lstStyle/>
           <a:p>
-            <a:pPr marL="0" indent="0">
-              <a:buNone/>
-            </a:pPr>
-            <a:r>
-              <a:rPr sz="900">
-                <a:solidFill>
-                  <a:srgbClr val="1E293B"/>
-                </a:solidFill>
+            <a:pPr algn="l"/>
+            <a:r>
+              <a:rPr sz="900" b="0">
+                <a:solidFill>
+                  <a:srgbClr val="0F172A"/>
+                </a:solidFill>
+                <a:latin typeface="Aptos"/>
               </a:rPr>
               <a:t>Python 3.12, Streamlit 1.42+, Pydantic v2, Requests, Pandas, Pytest, Cirrascale Qualcomm Cloud AI (OpenAI REST protocol)</a:t>
             </a:r>
-            <a:endParaRPr lang="en-US" sz="1200" dirty="0"/>
           </a:p>
         </p:txBody>
       </p:sp>
@@ -5466,32 +5379,33 @@
           <a:ln/>
         </p:spPr>
         <p:txBody>
-          <a:bodyPr wrap="square" lIns="254" tIns="254" rIns="254" bIns="254" rtlCol="0" anchor="ctr">
+          <a:bodyPr wrap="square" lIns="36576" tIns="36576" rIns="36576" bIns="36576" rtlCol="0" anchor="ctr">
             <a:normAutofit/>
           </a:bodyPr>
           <a:lstStyle/>
           <a:p>
-            <a:pPr marL="0" indent="0">
-              <a:buNone/>
-            </a:pPr>
-            <a:r>
-              <a:rPr sz="850">
-                <a:solidFill>
-                  <a:srgbClr val="1E293B"/>
-                </a:solidFill>
+            <a:pPr algn="l"/>
+            <a:r>
+              <a:rPr sz="850" b="0">
+                <a:solidFill>
+                  <a:srgbClr val="0F172A"/>
+                </a:solidFill>
+                <a:latin typeface="Aptos"/>
               </a:rPr>
               <a:t>• Single-Request Invariant: Guarantees staying within $3 budget (~3,820 runs).</a:t>
             </a:r>
-            <a:br/>
-            <a:r>
-              <a:rPr sz="850">
-                <a:solidFill>
-                  <a:srgbClr val="1E293B"/>
-                </a:solidFill>
+          </a:p>
+          <a:p>
+            <a:pPr algn="l"/>
+            <a:r>
+              <a:rPr sz="850" b="0">
+                <a:solidFill>
+                  <a:srgbClr val="0F172A"/>
+                </a:solidFill>
+                <a:latin typeface="Aptos"/>
               </a:rPr>
               <a:t>• Separation of Concerns: LLM handles semantics; deterministic code audits business integrity.</a:t>
             </a:r>
-            <a:endParaRPr lang="en-US" sz="1200" dirty="0"/>
           </a:p>
         </p:txBody>
       </p:sp>
@@ -5602,32 +5516,33 @@
           <a:ln/>
         </p:spPr>
         <p:txBody>
-          <a:bodyPr wrap="square" lIns="254" tIns="254" rIns="254" bIns="254" rtlCol="0" anchor="ctr">
+          <a:bodyPr wrap="square" lIns="36576" tIns="36576" rIns="36576" bIns="36576" rtlCol="0" anchor="ctr">
             <a:normAutofit/>
           </a:bodyPr>
           <a:lstStyle/>
           <a:p>
-            <a:pPr marL="0" indent="0">
-              <a:buNone/>
-            </a:pPr>
-            <a:r>
-              <a:rPr sz="850">
-                <a:solidFill>
-                  <a:srgbClr val="16A34A"/>
-                </a:solidFill>
+            <a:pPr algn="l"/>
+            <a:r>
+              <a:rPr sz="850" b="0">
+                <a:solidFill>
+                  <a:srgbClr val="0F172A"/>
+                </a:solidFill>
+                <a:latin typeface="Aptos"/>
               </a:rPr>
               <a:t>• 30 Automated Pytest Tests (100% Pass Rate) covering schemas, heuristics, and network drops (401, 429, timeout).</a:t>
             </a:r>
-            <a:br/>
-            <a:r>
-              <a:rPr sz="850">
-                <a:solidFill>
-                  <a:srgbClr val="16A34A"/>
-                </a:solidFill>
+          </a:p>
+          <a:p>
+            <a:pPr algn="l"/>
+            <a:r>
+              <a:rPr sz="850" b="0">
+                <a:solidFill>
+                  <a:srgbClr val="0F172A"/>
+                </a:solidFill>
+                <a:latin typeface="Aptos"/>
               </a:rPr>
               <a:t>• Fail-safe zero-credit benchmark mode.</a:t>
             </a:r>
-            <a:endParaRPr lang="en-US" sz="1200" dirty="0"/>
           </a:p>
         </p:txBody>
       </p:sp>
@@ -6229,32 +6144,33 @@
           <a:ln/>
         </p:spPr>
         <p:txBody>
-          <a:bodyPr wrap="square" lIns="254" tIns="254" rIns="254" bIns="254" rtlCol="0" anchor="ctr">
+          <a:bodyPr wrap="square" lIns="36576" tIns="36576" rIns="36576" bIns="36576" rtlCol="0" anchor="ctr">
             <a:normAutofit fontScale="62500" lnSpcReduction="20000"/>
           </a:bodyPr>
           <a:lstStyle/>
           <a:p>
-            <a:pPr marL="0" indent="0">
-              <a:buNone/>
-            </a:pPr>
-            <a:r>
-              <a:rPr sz="1000">
-                <a:solidFill>
-                  <a:srgbClr val="1E293B"/>
-                </a:solidFill>
+            <a:pPr algn="l"/>
+            <a:r>
+              <a:rPr sz="1000" b="0">
+                <a:solidFill>
+                  <a:srgbClr val="0F172A"/>
+                </a:solidFill>
+                <a:latin typeface="Aptos"/>
               </a:rPr>
               <a:t>Hardware-accelerated LLM on Qualcomm Cloud AI (Cirrascale Inference Suite)</a:t>
             </a:r>
-            <a:br/>
-            <a:r>
-              <a:rPr sz="1000">
-                <a:solidFill>
-                  <a:srgbClr val="1E293B"/>
-                </a:solidFill>
+          </a:p>
+          <a:p>
+            <a:pPr algn="l"/>
+            <a:r>
+              <a:rPr sz="1000" b="0">
+                <a:solidFill>
+                  <a:srgbClr val="0F172A"/>
+                </a:solidFill>
+                <a:latin typeface="Aptos"/>
               </a:rPr>
               <a:t>• Models: DeepSeek-R1-Distill-Llama-70B &amp; Llama-3.1-8B</a:t>
             </a:r>
-            <a:endParaRPr lang="en-US" sz="1900" dirty="0"/>
           </a:p>
         </p:txBody>
       </p:sp>
@@ -6365,23 +6281,21 @@
           <a:ln/>
         </p:spPr>
         <p:txBody>
-          <a:bodyPr wrap="square" lIns="254" tIns="254" rIns="254" bIns="254" rtlCol="0" anchor="ctr">
+          <a:bodyPr wrap="square" lIns="36576" tIns="36576" rIns="36576" bIns="36576" rtlCol="0" anchor="ctr">
             <a:normAutofit/>
           </a:bodyPr>
           <a:lstStyle/>
           <a:p>
-            <a:pPr marL="0" indent="0">
-              <a:buNone/>
-            </a:pPr>
-            <a:r>
-              <a:rPr sz="950">
-                <a:solidFill>
-                  <a:srgbClr val="1E293B"/>
-                </a:solidFill>
+            <a:pPr algn="l"/>
+            <a:r>
+              <a:rPr sz="950" b="0">
+                <a:solidFill>
+                  <a:srgbClr val="0F172A"/>
+                </a:solidFill>
+                <a:latin typeface="Aptos"/>
               </a:rPr>
               <a:t>Dual-Layer Hybrid Intelligence: Generative extraction paired with deterministic symbolic auditing. Proactively generates clarification questions instead of guessing.</a:t>
             </a:r>
-            <a:endParaRPr lang="en-US" sz="1200" dirty="0"/>
           </a:p>
         </p:txBody>
       </p:sp>
@@ -6491,23 +6405,21 @@
           <a:ln/>
         </p:spPr>
         <p:txBody>
-          <a:bodyPr wrap="square" lIns="254" tIns="254" rIns="254" bIns="254" rtlCol="0" anchor="ctr">
+          <a:bodyPr wrap="square" lIns="36576" tIns="36576" rIns="36576" bIns="36576" rtlCol="0" anchor="ctr">
             <a:normAutofit/>
           </a:bodyPr>
           <a:lstStyle/>
           <a:p>
-            <a:pPr marL="0" indent="0">
-              <a:buNone/>
-            </a:pPr>
-            <a:r>
-              <a:rPr sz="900">
-                <a:solidFill>
-                  <a:srgbClr val="1E293B"/>
-                </a:solidFill>
+            <a:pPr algn="l"/>
+            <a:r>
+              <a:rPr sz="900" b="0">
+                <a:solidFill>
+                  <a:srgbClr val="0F172A"/>
+                </a:solidFill>
+                <a:latin typeface="Aptos"/>
               </a:rPr>
               <a:t>Semantic extraction of actionable tasks, isolation of confirmed decisions vs tentative proposals, and verbatim citation grounding.</a:t>
             </a:r>
-            <a:endParaRPr lang="en-US" sz="1150" dirty="0"/>
           </a:p>
         </p:txBody>
       </p:sp>
@@ -6617,23 +6529,21 @@
           <a:ln/>
         </p:spPr>
         <p:txBody>
-          <a:bodyPr wrap="square" lIns="254" tIns="254" rIns="254" bIns="254" rtlCol="0" anchor="ctr">
+          <a:bodyPr wrap="square" lIns="36576" tIns="36576" rIns="36576" bIns="36576" rtlCol="0" anchor="ctr">
             <a:normAutofit/>
           </a:bodyPr>
           <a:lstStyle/>
           <a:p>
-            <a:pPr marL="0" indent="0">
-              <a:buNone/>
-            </a:pPr>
-            <a:r>
-              <a:rPr sz="900">
-                <a:solidFill>
-                  <a:srgbClr val="1E293B"/>
-                </a:solidFill>
+            <a:pPr algn="l"/>
+            <a:r>
+              <a:rPr sz="900" b="0">
+                <a:solidFill>
+                  <a:srgbClr val="0F172A"/>
+                </a:solidFill>
+                <a:latin typeface="Aptos"/>
               </a:rPr>
               <a:t>Cirrascale Qualcomm Cloud AI running DeepSeek-R1 (for reasoning traces) and Llama-3.1 (for fast edge inference).</a:t>
             </a:r>
-            <a:endParaRPr lang="en-US" sz="1150" dirty="0"/>
           </a:p>
         </p:txBody>
       </p:sp>
@@ -6743,23 +6653,21 @@
           <a:ln/>
         </p:spPr>
         <p:txBody>
-          <a:bodyPr wrap="square" lIns="254" tIns="254" rIns="254" bIns="254" rtlCol="0" anchor="ctr">
+          <a:bodyPr wrap="square" lIns="36576" tIns="36576" rIns="36576" bIns="36576" rtlCol="0" anchor="ctr">
             <a:normAutofit/>
           </a:bodyPr>
           <a:lstStyle/>
           <a:p>
-            <a:pPr marL="0" indent="0">
-              <a:buNone/>
-            </a:pPr>
-            <a:r>
-              <a:rPr sz="850">
-                <a:solidFill>
-                  <a:srgbClr val="1E293B"/>
-                </a:solidFill>
+            <a:pPr algn="l"/>
+            <a:r>
+              <a:rPr sz="850" b="0">
+                <a:solidFill>
+                  <a:srgbClr val="0F172A"/>
+                </a:solidFill>
+                <a:latin typeface="Aptos"/>
               </a:rPr>
               <a:t>Verbatim citations enforced for all tasks/decisions; reasoning constrained to &lt;50 words (slashing latency to 25s); Pydantic type validation; 30 unit tests.</a:t>
             </a:r>
-            <a:endParaRPr lang="en-US" sz="1150" dirty="0"/>
           </a:p>
         </p:txBody>
       </p:sp>
@@ -6869,23 +6777,21 @@
           <a:ln/>
         </p:spPr>
         <p:txBody>
-          <a:bodyPr wrap="square" lIns="254" tIns="254" rIns="254" bIns="254" rtlCol="0" anchor="ctr">
+          <a:bodyPr wrap="square" lIns="36576" tIns="36576" rIns="36576" bIns="36576" rtlCol="0" anchor="ctr">
             <a:normAutofit/>
           </a:bodyPr>
           <a:lstStyle/>
           <a:p>
-            <a:pPr marL="0" indent="0">
-              <a:buNone/>
-            </a:pPr>
-            <a:r>
-              <a:rPr sz="850">
-                <a:solidFill>
-                  <a:srgbClr val="16A34A"/>
-                </a:solidFill>
+            <a:pPr algn="l"/>
+            <a:r>
+              <a:rPr sz="850" b="0">
+                <a:solidFill>
+                  <a:srgbClr val="0F172A"/>
+                </a:solidFill>
+                <a:latin typeface="Aptos"/>
               </a:rPr>
               <a:t>90% reduction in post-meeting triage time. Official Cirrascale unit economics: $0.00078 per meeting on 70B (&lt; 1/10th of a cent), costing &lt; $1.00/month for 1,000 enterprise meetings.</a:t>
             </a:r>
-            <a:endParaRPr lang="en-US" sz="1150" dirty="0"/>
           </a:p>
         </p:txBody>
       </p:sp>
@@ -7567,23 +7473,21 @@
           <a:ln/>
         </p:spPr>
         <p:txBody>
-          <a:bodyPr wrap="square" lIns="254" tIns="254" rIns="254" bIns="254" rtlCol="0" anchor="ctr">
+          <a:bodyPr wrap="square" lIns="36576" tIns="36576" rIns="36576" bIns="36576" rtlCol="0" anchor="ctr">
             <a:normAutofit/>
           </a:bodyPr>
           <a:lstStyle/>
           <a:p>
-            <a:pPr marL="0" indent="0">
-              <a:buNone/>
-            </a:pPr>
-            <a:r>
-              <a:rPr sz="900">
-                <a:solidFill>
-                  <a:srgbClr val="1E293B"/>
-                </a:solidFill>
+            <a:pPr algn="l"/>
+            <a:r>
+              <a:rPr sz="850" b="0">
+                <a:solidFill>
+                  <a:srgbClr val="0F172A"/>
+                </a:solidFill>
+                <a:latin typeface="Aptos"/>
               </a:rPr>
               <a:t>Live Audio &amp; On-Device NPU Transcription: Whisper model integration running locally on Snapdragon X Elite NPU hardware.</a:t>
             </a:r>
-            <a:endParaRPr lang="en-US" sz="1150" dirty="0"/>
           </a:p>
         </p:txBody>
       </p:sp>
@@ -7691,23 +7595,21 @@
           <a:ln/>
         </p:spPr>
         <p:txBody>
-          <a:bodyPr wrap="square" lIns="254" tIns="254" rIns="254" bIns="254" rtlCol="0" anchor="ctr">
+          <a:bodyPr wrap="square" lIns="36576" tIns="36576" rIns="36576" bIns="36576" rtlCol="0" anchor="ctr">
             <a:normAutofit/>
           </a:bodyPr>
           <a:lstStyle/>
           <a:p>
-            <a:pPr marL="0" indent="0">
-              <a:buNone/>
-            </a:pPr>
-            <a:r>
-              <a:rPr sz="900">
-                <a:solidFill>
-                  <a:srgbClr val="1E293B"/>
-                </a:solidFill>
+            <a:pPr algn="l"/>
+            <a:r>
+              <a:rPr sz="850" b="0">
+                <a:solidFill>
+                  <a:srgbClr val="0F172A"/>
+                </a:solidFill>
+                <a:latin typeface="Aptos"/>
               </a:rPr>
               <a:t>Two-Way Enterprise Ticketing: Direct REST API connectors for Jira, Linear, Asana, and GitHub Issues.</a:t>
             </a:r>
-            <a:endParaRPr lang="en-US" sz="1150" dirty="0"/>
           </a:p>
         </p:txBody>
       </p:sp>
@@ -7815,23 +7717,21 @@
           <a:ln/>
         </p:spPr>
         <p:txBody>
-          <a:bodyPr wrap="square" lIns="254" tIns="254" rIns="254" bIns="254" rtlCol="0" anchor="ctr">
+          <a:bodyPr wrap="square" lIns="36576" tIns="36576" rIns="36576" bIns="36576" rtlCol="0" anchor="ctr">
             <a:normAutofit/>
           </a:bodyPr>
           <a:lstStyle/>
           <a:p>
-            <a:pPr marL="0" indent="0">
-              <a:buNone/>
-            </a:pPr>
-            <a:r>
-              <a:rPr sz="900">
-                <a:solidFill>
-                  <a:srgbClr val="1E293B"/>
-                </a:solidFill>
+            <a:pPr algn="l"/>
+            <a:r>
+              <a:rPr sz="850" b="0">
+                <a:solidFill>
+                  <a:srgbClr val="0F172A"/>
+                </a:solidFill>
+                <a:latin typeface="Aptos"/>
               </a:rPr>
               <a:t>Automated Slack / Microsoft Teams Bot: Proactively pings owners on Slack to confirm tentative assignments or clarify vague deadlines.</a:t>
             </a:r>
-            <a:endParaRPr lang="en-US" sz="1150" dirty="0"/>
           </a:p>
         </p:txBody>
       </p:sp>
@@ -8022,23 +7922,21 @@
           <a:ln/>
         </p:spPr>
         <p:txBody>
-          <a:bodyPr wrap="square" lIns="254" tIns="254" rIns="254" bIns="254" rtlCol="0" anchor="ctr">
+          <a:bodyPr wrap="square" lIns="36576" tIns="36576" rIns="36576" bIns="36576" rtlCol="0" anchor="ctr">
             <a:normAutofit/>
           </a:bodyPr>
           <a:lstStyle/>
           <a:p>
-            <a:pPr marL="0" indent="0">
-              <a:buNone/>
-            </a:pPr>
-            <a:r>
-              <a:rPr sz="900">
-                <a:solidFill>
-                  <a:srgbClr val="1E293B"/>
-                </a:solidFill>
+            <a:pPr algn="l"/>
+            <a:r>
+              <a:rPr sz="850" b="0">
+                <a:solidFill>
+                  <a:srgbClr val="0F172A"/>
+                </a:solidFill>
+                <a:latin typeface="Aptos"/>
               </a:rPr>
               <a:t>Stateless microservice containerization deployable on Kubernetes across multi-tenant enterprise clusters.</a:t>
             </a:r>
-            <a:endParaRPr lang="en-US" sz="1150" dirty="0"/>
           </a:p>
         </p:txBody>
       </p:sp>
@@ -8146,23 +8044,21 @@
           <a:ln/>
         </p:spPr>
         <p:txBody>
-          <a:bodyPr wrap="square" lIns="254" tIns="254" rIns="254" bIns="254" rtlCol="0" anchor="ctr">
+          <a:bodyPr wrap="square" lIns="36576" tIns="36576" rIns="36576" bIns="36576" rtlCol="0" anchor="ctr">
             <a:normAutofit/>
           </a:bodyPr>
           <a:lstStyle/>
           <a:p>
-            <a:pPr marL="0" indent="0">
-              <a:buNone/>
-            </a:pPr>
-            <a:r>
-              <a:rPr sz="900">
-                <a:solidFill>
-                  <a:srgbClr val="1E293B"/>
-                </a:solidFill>
+            <a:pPr algn="l"/>
+            <a:r>
+              <a:rPr sz="850" b="0">
+                <a:solidFill>
+                  <a:srgbClr val="0F172A"/>
+                </a:solidFill>
+                <a:latin typeface="Aptos"/>
               </a:rPr>
               <a:t>100% on-device NPU processing on Snapdragon laptops via Qualcomm AI Hub with zero cloud cost.</a:t>
             </a:r>
-            <a:endParaRPr lang="en-US" sz="1150" dirty="0"/>
           </a:p>
         </p:txBody>
       </p:sp>
@@ -8270,23 +8166,21 @@
           <a:ln/>
         </p:spPr>
         <p:txBody>
-          <a:bodyPr wrap="square" lIns="254" tIns="254" rIns="254" bIns="254" rtlCol="0" anchor="ctr">
+          <a:bodyPr wrap="square" lIns="36576" tIns="36576" rIns="36576" bIns="36576" rtlCol="0" anchor="ctr">
             <a:normAutofit/>
           </a:bodyPr>
           <a:lstStyle/>
           <a:p>
-            <a:pPr marL="0" indent="0">
-              <a:buNone/>
-            </a:pPr>
-            <a:r>
-              <a:rPr sz="900">
-                <a:solidFill>
-                  <a:srgbClr val="1E293B"/>
-                </a:solidFill>
+            <a:pPr algn="l"/>
+            <a:r>
+              <a:rPr sz="850" b="0">
+                <a:solidFill>
+                  <a:srgbClr val="0F172A"/>
+                </a:solidFill>
+                <a:latin typeface="Aptos"/>
               </a:rPr>
               <a:t>Token bucket rate-limiting with exponential backoff handling 10,000+ concurrent summaries.</a:t>
             </a:r>
-            <a:endParaRPr lang="en-US" sz="1150" dirty="0"/>
           </a:p>
         </p:txBody>
       </p:sp>
@@ -8477,23 +8371,21 @@
           <a:ln/>
         </p:spPr>
         <p:txBody>
-          <a:bodyPr wrap="square" lIns="254" tIns="254" rIns="254" bIns="254" rtlCol="0" anchor="ctr">
+          <a:bodyPr wrap="square" lIns="36576" tIns="36576" rIns="36576" bIns="36576" rtlCol="0" anchor="ctr">
             <a:normAutofit/>
           </a:bodyPr>
           <a:lstStyle/>
           <a:p>
-            <a:pPr marL="0" indent="0">
-              <a:buNone/>
-            </a:pPr>
-            <a:r>
-              <a:rPr sz="900">
-                <a:solidFill>
-                  <a:srgbClr val="1E293B"/>
-                </a:solidFill>
+            <a:pPr algn="l"/>
+            <a:r>
+              <a:rPr sz="850" b="0">
+                <a:solidFill>
+                  <a:srgbClr val="0F172A"/>
+                </a:solidFill>
+                <a:latin typeface="Aptos"/>
               </a:rPr>
               <a:t>Role-based enterprise access control (RBAC) and encrypted credential management (.env isolation).</a:t>
             </a:r>
-            <a:endParaRPr lang="en-US" sz="1150" dirty="0"/>
           </a:p>
         </p:txBody>
       </p:sp>
@@ -8601,23 +8493,21 @@
           <a:ln/>
         </p:spPr>
         <p:txBody>
-          <a:bodyPr wrap="square" lIns="254" tIns="254" rIns="254" bIns="254" rtlCol="0" anchor="ctr">
+          <a:bodyPr wrap="square" lIns="36576" tIns="36576" rIns="36576" bIns="36576" rtlCol="0" anchor="ctr">
             <a:normAutofit/>
           </a:bodyPr>
           <a:lstStyle/>
           <a:p>
-            <a:pPr marL="0" indent="0">
-              <a:buNone/>
-            </a:pPr>
-            <a:r>
-              <a:rPr sz="900">
-                <a:solidFill>
-                  <a:srgbClr val="1E293B"/>
-                </a:solidFill>
+            <a:pPr algn="l"/>
+            <a:r>
+              <a:rPr sz="850" b="0">
+                <a:solidFill>
+                  <a:srgbClr val="0F172A"/>
+                </a:solidFill>
+                <a:latin typeface="Aptos"/>
               </a:rPr>
               <a:t>Zero persistent transcript retention — raw text is parsed in-memory and immediately purged (GDPR/HIPAA compliant).</a:t>
             </a:r>
-            <a:endParaRPr lang="en-US" sz="1150" dirty="0"/>
           </a:p>
         </p:txBody>
       </p:sp>
@@ -8725,23 +8615,21 @@
           <a:ln/>
         </p:spPr>
         <p:txBody>
-          <a:bodyPr wrap="square" lIns="254" tIns="254" rIns="254" bIns="254" rtlCol="0" anchor="ctr">
+          <a:bodyPr wrap="square" lIns="36576" tIns="36576" rIns="36576" bIns="36576" rtlCol="0" anchor="ctr">
             <a:normAutofit/>
           </a:bodyPr>
           <a:lstStyle/>
           <a:p>
-            <a:pPr marL="0" indent="0">
-              <a:buNone/>
-            </a:pPr>
-            <a:r>
-              <a:rPr sz="900">
-                <a:solidFill>
-                  <a:srgbClr val="1E293B"/>
-                </a:solidFill>
+            <a:pPr algn="l"/>
+            <a:r>
+              <a:rPr sz="850" b="0">
+                <a:solidFill>
+                  <a:srgbClr val="0F172A"/>
+                </a:solidFill>
+                <a:latin typeface="Aptos"/>
               </a:rPr>
               <a:t>Human-in-the-loop triage: AI confidence signals with mandatory human sign-off before downstream ticketing export.</a:t>
             </a:r>
-            <a:endParaRPr lang="en-US" sz="1150" dirty="0"/>
           </a:p>
         </p:txBody>
       </p:sp>
@@ -9121,304 +9009,106 @@
         </p:nvSpPr>
         <p:spPr>
           <a:xfrm>
-            <a:off x="3297836" y="2173574"/>
-            <a:ext cx="5801194" cy="1015663"/>
-          </a:xfrm>
-          <a:prstGeom prst="rect">
-            <a:avLst/>
-          </a:prstGeom>
-          <a:noFill/>
-        </p:spPr>
-        <p:txBody>
-          <a:bodyPr wrap="square" rtlCol="0">
+            <a:off x="1097280" y="1371600"/>
+            <a:ext cx="9966960" cy="4389120"/>
+          </a:xfrm>
+          <a:prstGeom prst="rect">
+            <a:avLst/>
+          </a:prstGeom>
+          <a:noFill/>
+        </p:spPr>
+        <p:txBody>
+          <a:bodyPr wrap="square" rtlCol="0" tIns="91440" bIns="91440">
             <a:spAutoFit/>
           </a:bodyPr>
           <a:lstStyle/>
           <a:p>
-            <a:pPr algn="ctr">
-              <a:defRPr sz="2800" b="1">
-                <a:solidFill>
-                  <a:srgbClr val="4F46E5"/>
-                </a:solidFill>
-              </a:defRPr>
-            </a:pPr>
-            <a:r>
-              <a:t>LIVE DEMONSTRATION</a:t>
-            </a:r>
-          </a:p>
-        </p:txBody>
-      </p:sp>
-      <p:sp>
-        <p:nvSpPr>
-          <p:cNvPr id="3" name="TextBox 2"/>
-          <p:cNvSpPr txBox="1"/>
-          <p:nvPr/>
-        </p:nvSpPr>
-        <p:spPr>
-          <a:xfrm>
-            <a:off x="2743200" y="3108960"/>
-            <a:ext cx="6702552" cy="457200"/>
-          </a:xfrm>
-          <a:prstGeom prst="rect">
-            <a:avLst/>
-          </a:prstGeom>
-          <a:noFill/>
-        </p:spPr>
-        <p:txBody>
-          <a:bodyPr wrap="none">
-            <a:spAutoFit/>
-          </a:bodyPr>
-          <a:lstStyle/>
-          <a:p>
-            <a:pPr algn="ctr">
-              <a:defRPr sz="1400" b="1">
+            <a:pPr algn="ctr"/>
+            <a:r>
+              <a:rPr sz="2800" b="1">
+                <a:solidFill>
+                  <a:srgbClr val="003B7A"/>
+                </a:solidFill>
+                <a:latin typeface="Aptos Display"/>
+              </a:rPr>
+              <a:t>LIVE DEMONSTRATION: MEETINGMIND AI</a:t>
+            </a:r>
+          </a:p>
+          <a:p>
+            <a:pPr algn="ctr"/>
+            <a:r>
+              <a:rPr sz="1300" b="1">
+                <a:solidFill>
+                  <a:srgbClr val="475569"/>
+                </a:solidFill>
+                <a:latin typeface="Aptos"/>
+              </a:rPr>
+              <a:t>Problem EP-01: Smart Meeting Action Extractor  •  Qualcomm Cloud AI Track  •  http://localhost:8501</a:t>
+            </a:r>
+          </a:p>
+          <a:p/>
+          <a:p>
+            <a:pPr algn="l"/>
+            <a:r>
+              <a:rPr sz="1100">
                 <a:solidFill>
                   <a:srgbClr val="0F172A"/>
                 </a:solidFill>
-              </a:defRPr>
-            </a:pPr>
-            <a:r>
-              <a:t>MeetingMind AI Running Live on Qualcomm Cloud AI • http://localhost:8501</a:t>
-            </a:r>
-          </a:p>
-        </p:txBody>
-      </p:sp>
-      <p:sp>
-        <p:nvSpPr>
-          <p:cNvPr id="4" name="Rounded Rectangle 3"/>
-          <p:cNvSpPr/>
-          <p:nvPr/>
-        </p:nvSpPr>
-        <p:spPr>
-          <a:xfrm>
-            <a:off x="1371600" y="3840480"/>
-            <a:ext cx="4389120" cy="2377440"/>
-          </a:xfrm>
-          <a:prstGeom prst="roundRect">
-            <a:avLst/>
-          </a:prstGeom>
-          <a:solidFill>
-            <a:srgbClr val="F8FAFC"/>
-          </a:solidFill>
-          <a:ln>
-            <a:solidFill>
-              <a:srgbClr val="CBD5E1"/>
-            </a:solidFill>
-          </a:ln>
-        </p:spPr>
-        <p:style>
-          <a:lnRef idx="1">
-            <a:schemeClr val="accent1"/>
-          </a:lnRef>
-          <a:fillRef idx="3">
-            <a:schemeClr val="accent1"/>
-          </a:fillRef>
-          <a:effectRef idx="2">
-            <a:schemeClr val="accent1"/>
-          </a:effectRef>
-          <a:fontRef idx="minor">
-            <a:schemeClr val="lt1"/>
-          </a:fontRef>
-        </p:style>
-        <p:txBody>
-          <a:bodyPr rtlCol="0" anchor="ctr" wrap="square"/>
-          <a:lstStyle/>
-          <a:p>
-            <a:pPr algn="ctr">
-              <a:defRPr b="1" sz="1100">
-                <a:solidFill>
-                  <a:srgbClr val="4F46E5"/>
-                </a:solidFill>
-              </a:defRPr>
-            </a:pPr>
-            <a:r>
-              <a:t>LIVE DEMO STEPS</a:t>
-            </a:r>
-          </a:p>
-          <a:p>
-            <a:pPr>
-              <a:defRPr sz="950">
-                <a:solidFill>
-                  <a:srgbClr val="1E293B"/>
-                </a:solidFill>
-              </a:defRPr>
-            </a:pPr>
-            <a:r>
-              <a:t>1. Sidebar Health Check: Live AI connected to Cirrascale.</a:t>
-            </a:r>
-          </a:p>
-          <a:p>
-            <a:pPr>
-              <a:defRPr sz="950">
-                <a:solidFill>
-                  <a:srgbClr val="1E293B"/>
-                </a:solidFill>
-              </a:defRPr>
-            </a:pPr>
-            <a:r>
-              <a:t>2. Input Notes: Load benchmark notes with unassigned tasks.</a:t>
-            </a:r>
-          </a:p>
-          <a:p>
-            <a:pPr>
-              <a:defRPr sz="950">
-                <a:solidFill>
-                  <a:srgbClr val="1E293B"/>
-                </a:solidFill>
-              </a:defRPr>
-            </a:pPr>
-            <a:r>
-              <a:t>3. Live Inference: DeepSeek-R1 execution on Qualcomm hardware.</a:t>
-            </a:r>
-          </a:p>
-          <a:p>
-            <a:pPr>
-              <a:defRPr sz="950">
-                <a:solidFill>
-                  <a:srgbClr val="1E293B"/>
-                </a:solidFill>
-              </a:defRPr>
-            </a:pPr>
-            <a:r>
-              <a:t>4. Triage Table: Filter by priority, owner, and status.</a:t>
-            </a:r>
-          </a:p>
-          <a:p>
-            <a:pPr>
-              <a:defRPr sz="950">
-                <a:solidFill>
-                  <a:srgbClr val="1E293B"/>
-                </a:solidFill>
-              </a:defRPr>
-            </a:pPr>
-            <a:r>
-              <a:t>5. Export: Download RFC-compliant Jira/Asana CSV.</a:t>
-            </a:r>
-          </a:p>
-        </p:txBody>
-      </p:sp>
-      <p:sp>
-        <p:nvSpPr>
-          <p:cNvPr id="5" name="Rounded Rectangle 4"/>
-          <p:cNvSpPr/>
-          <p:nvPr/>
-        </p:nvSpPr>
-        <p:spPr>
-          <a:xfrm>
-            <a:off x="6400800" y="3840480"/>
-            <a:ext cx="4389120" cy="2377440"/>
-          </a:xfrm>
-          <a:prstGeom prst="roundRect">
-            <a:avLst/>
-          </a:prstGeom>
-          <a:solidFill>
-            <a:srgbClr val="F8FAFC"/>
-          </a:solidFill>
-          <a:ln>
-            <a:solidFill>
-              <a:srgbClr val="CBD5E1"/>
-            </a:solidFill>
-          </a:ln>
-        </p:spPr>
-        <p:style>
-          <a:lnRef idx="1">
-            <a:schemeClr val="accent1"/>
-          </a:lnRef>
-          <a:fillRef idx="3">
-            <a:schemeClr val="accent1"/>
-          </a:fillRef>
-          <a:effectRef idx="2">
-            <a:schemeClr val="accent1"/>
-          </a:effectRef>
-          <a:fontRef idx="minor">
-            <a:schemeClr val="lt1"/>
-          </a:fontRef>
-        </p:style>
-        <p:txBody>
-          <a:bodyPr rtlCol="0" anchor="ctr" wrap="square"/>
-          <a:lstStyle/>
-          <a:p>
-            <a:pPr algn="ctr">
-              <a:defRPr b="1" sz="1100">
-                <a:solidFill>
-                  <a:srgbClr val="4F46E5"/>
-                </a:solidFill>
-              </a:defRPr>
-            </a:pPr>
-            <a:r>
-              <a:t>WHAT THE JUDGES WILL SEE</a:t>
-            </a:r>
-          </a:p>
-          <a:p>
-            <a:pPr>
-              <a:defRPr sz="950">
-                <a:solidFill>
-                  <a:srgbClr val="1E293B"/>
-                </a:solidFill>
-              </a:defRPr>
-            </a:pPr>
-            <a:r>
-              <a:t>• Rahul (API Integration): Confirmed (Due: Friday)</a:t>
-            </a:r>
-          </a:p>
-          <a:p>
-            <a:pPr>
-              <a:defRPr sz="950">
-                <a:solidFill>
-                  <a:srgbClr val="1E293B"/>
-                </a:solidFill>
-              </a:defRPr>
-            </a:pPr>
-            <a:r>
-              <a:t>• Priya (Testing): Tentative Flag ('Not confirmed')</a:t>
-            </a:r>
-          </a:p>
-          <a:p>
-            <a:pPr>
-              <a:defRPr sz="950">
-                <a:solidFill>
-                  <a:srgbClr val="1E293B"/>
-                </a:solidFill>
-              </a:defRPr>
-            </a:pPr>
-            <a:r>
-              <a:t>• Deployment Plan: Missing Owner + Vague Date ('soon')</a:t>
-            </a:r>
-          </a:p>
-          <a:p>
-            <a:pPr>
-              <a:defRPr sz="950">
-                <a:solidFill>
-                  <a:srgbClr val="1E293B"/>
-                </a:solidFill>
-              </a:defRPr>
-            </a:pPr>
-            <a:r>
-              <a:t>• Database Tech: Undecided Technical Decision</a:t>
-            </a:r>
-          </a:p>
-          <a:p>
-            <a:pPr>
-              <a:defRPr sz="950">
-                <a:solidFill>
-                  <a:srgbClr val="1E293B"/>
-                </a:solidFill>
-              </a:defRPr>
-            </a:pPr>
-            <a:r>
-              <a:t>• Interface Review: Confirmed Decision ('tomorrow')</a:t>
-            </a:r>
-          </a:p>
-          <a:p>
-            <a:pPr>
-              <a:defRPr sz="950">
-                <a:solidFill>
-                  <a:srgbClr val="1E293B"/>
-                </a:solidFill>
-              </a:defRPr>
-            </a:pPr>
-            <a:r>
-              <a:t>• Test Suite: 30 Pytest Tests Passing (100%)</a:t>
+                <a:latin typeface="Aptos"/>
+              </a:rPr>
+              <a:t>1. Sidebar Health Check: Live status indicator verifying active handshake with Cirrascale Qualcomm Cloud AI API.</a:t>
+            </a:r>
+          </a:p>
+          <a:p/>
+          <a:p>
+            <a:pPr algn="l"/>
+            <a:r>
+              <a:rPr sz="1100">
+                <a:solidFill>
+                  <a:srgbClr val="0F172A"/>
+                </a:solidFill>
+                <a:latin typeface="Aptos"/>
+              </a:rPr>
+              <a:t>2. Messy Benchmark Transcript: 1-Click loading of real-world notes containing implicit commitments, tentative offers &amp; unassigned work.</a:t>
+            </a:r>
+          </a:p>
+          <a:p/>
+          <a:p>
+            <a:pPr algn="l"/>
+            <a:r>
+              <a:rPr sz="1100">
+                <a:solidFill>
+                  <a:srgbClr val="0F172A"/>
+                </a:solidFill>
+                <a:latin typeface="Aptos"/>
+              </a:rPr>
+              <a:t>3. Live Hardware Execution: Real-time inference using DeepSeek-R1-Distill-70B on Qualcomm Cloud AI with verbatim quote grounding.</a:t>
+            </a:r>
+          </a:p>
+          <a:p/>
+          <a:p>
+            <a:pPr algn="l"/>
+            <a:r>
+              <a:rPr sz="1100">
+                <a:solidFill>
+                  <a:srgbClr val="0F172A"/>
+                </a:solidFill>
+                <a:latin typeface="Aptos"/>
+              </a:rPr>
+              <a:t>4. Anti-Hallucination Triage: Interactive table isolating missing owners &amp; vague dates, surfacing proactive Clarification Questions.</a:t>
+            </a:r>
+          </a:p>
+          <a:p/>
+          <a:p>
+            <a:pPr algn="l"/>
+            <a:r>
+              <a:rPr sz="1100">
+                <a:solidFill>
+                  <a:srgbClr val="0F172A"/>
+                </a:solidFill>
+                <a:latin typeface="Aptos"/>
+              </a:rPr>
+              <a:t>5. Enterprise Deliverables Export: 1-Click download of RFC-compliant Jira/Asana CSV and schema-validated JSON deliverables.</a:t>
             </a:r>
           </a:p>
         </p:txBody>

</xml_diff>

<commit_message>
Incorporate the 6 strict anti-hallucination rules and GMeet pipeline into official presentation
</commit_message>
<xml_diff>
--- a/Hack-AI-Thon_Solution_Presentation_Template.pptx
+++ b/Hack-AI-Thon_Solution_Presentation_Template.pptx
@@ -716,7 +716,7 @@
           <a:lstStyle/>
           <a:p>
             <a:r>
-              <a:t>WHAT TO SAY (55s): “Walking left to right through our architecture: the user interacts with our Streamlit frontend. The request routes to Cirrascale's Qualcomm Cloud AI hardware running DeepSeek-R1. We enforce an architectural Single-Request Invariant to protect the $3 budget. Our test suite includes 30 unit tests covering network drops, 401s, 429s, and edge cases, passing at 100%.”</a:t>
+              <a:t>WHAT TO SAY (55s): “Walking left to right through our architecture: the user interacts with our Streamlit frontend. The request routes to Cirrascale's Qualcomm Cloud AI hardware running DeepSeek-R1. We enforce an architectural Single-Request Invariant to protect the $3 budget. Our test suite includes 31 unit tests covering network drops, 401s, 429s, and edge cases, passing at 100%.”</a:t>
             </a:r>
           </a:p>
         </p:txBody>
@@ -786,7 +786,7 @@
           <a:lstStyle/>
           <a:p>
             <a:r>
-              <a:t>WHAT TO SAY (45s): “We use Qualcomm Cloud AI running DeepSeek-R1-Distill-70B for deep reasoning and Llama-3.1-8B for edge speed. Because we optimized prompt conciseness, extraction completes in 25 seconds. And look at the unit economics: on Cirrascale's official pricing, an entire meeting analysis costs less than a tenth of a cent—under $1 a month for 1,000 meetings!”</a:t>
+              <a:t>WHAT TO SAY (45s): “We run DeepSeek-R1-Distill-70B on Qualcomm Cloud AI under 6 strict extraction rules: 1) Strict Factual Accuracy with null-handling, 2) Confirmed vs Tentative separation, 3) Vague commitment flagging, 4) Mandatory verbatim quotes, 5) Confidence scoring, and 6) Reasoning conciseness under 50 words to slash latency to 25s. On Cirrascale's official pricing, an entire meeting analysis costs under a tenth of a cent—less than $1 a month for 1,000 meetings!”</a:t>
             </a:r>
           </a:p>
         </p:txBody>
@@ -3678,7 +3678,7 @@
           <a:p>
             <a:pPr algn="l"/>
             <a:r>
-              <a:rPr sz="950" b="0">
+              <a:rPr sz="900" b="0">
                 <a:solidFill>
                   <a:srgbClr val="0F172A"/>
                 </a:solidFill>
@@ -3690,19 +3690,19 @@
           <a:p>
             <a:pPr algn="l"/>
             <a:r>
-              <a:rPr sz="950" b="0">
+              <a:rPr sz="900" b="0">
                 <a:solidFill>
                   <a:srgbClr val="0F172A"/>
                 </a:solidFill>
                 <a:latin typeface="Aptos"/>
               </a:rPr>
-              <a:t>1. Qualcomm Cloud AI extracts entities backed by verbatim evidence quotes.</a:t>
+              <a:t>1. Qualcomm Cloud AI extracts entities governed by 6 Strict Rules.</a:t>
             </a:r>
           </a:p>
           <a:p>
             <a:pPr algn="l"/>
             <a:r>
-              <a:rPr sz="950" b="0">
+              <a:rPr sz="900" b="0">
                 <a:solidFill>
                   <a:srgbClr val="0F172A"/>
                 </a:solidFill>
@@ -4973,13 +4973,13 @@
           <a:p>
             <a:pPr algn="l"/>
             <a:r>
-              <a:rPr sz="900" b="0">
+              <a:rPr sz="850" b="0">
                 <a:solidFill>
                   <a:srgbClr val="0F172A"/>
                 </a:solidFill>
                 <a:latin typeface="Aptos"/>
               </a:rPr>
-              <a:t>Cirrascale Qualcomm Cloud AI (/apis/v2), DeepSeek-R1-Distill-70B &amp; Llama-3.1-8B, zero-hallucination prompt contract</a:t>
+              <a:t>Cirrascale Qualcomm Cloud AI (/apis/v2), DeepSeek-R1-Distill-70B governed by 6 Strict Rules &amp; Pydantic v2 schemas</a:t>
             </a:r>
           </a:p>
         </p:txBody>
@@ -5404,7 +5404,7 @@
                 </a:solidFill>
                 <a:latin typeface="Aptos"/>
               </a:rPr>
-              <a:t>• Separation of Concerns: LLM handles semantics; deterministic code audits business integrity.</a:t>
+              <a:t>• Separation of Concerns: LLM handles semantics under 6 rules; deterministic code audits business integrity.</a:t>
             </a:r>
           </a:p>
         </p:txBody>
@@ -5529,7 +5529,7 @@
                 </a:solidFill>
                 <a:latin typeface="Aptos"/>
               </a:rPr>
-              <a:t>• 30 Automated Pytest Tests (100% Pass Rate) covering schemas, heuristics, and network drops (401, 429, timeout).</a:t>
+              <a:t>• 31 Automated Pytest Tests (100% Pass Rate) covering schemas, heuristics, and network drops (401, 429, timeout).</a:t>
             </a:r>
           </a:p>
           <a:p>
@@ -6288,13 +6288,13 @@
           <a:p>
             <a:pPr algn="l"/>
             <a:r>
-              <a:rPr sz="950" b="0">
+              <a:rPr sz="900" b="0">
                 <a:solidFill>
                   <a:srgbClr val="0F172A"/>
                 </a:solidFill>
                 <a:latin typeface="Aptos"/>
               </a:rPr>
-              <a:t>Dual-Layer Hybrid Intelligence: Generative extraction paired with deterministic symbolic auditing. Proactively generates clarification questions instead of guessing.</a:t>
+              <a:t>Dual-Layer Hybrid Intelligence: Qualcomm LLM extraction enforced by 6 Strict Rules, paired with deterministic Python auditing to eliminate hallucinations.</a:t>
             </a:r>
           </a:p>
         </p:txBody>
@@ -6519,8 +6519,8 @@
         </p:nvSpPr>
         <p:spPr>
           <a:xfrm>
-            <a:off x="7699248" y="2322576"/>
-            <a:ext cx="3566160" cy="612648"/>
+            <a:off x="7699248" y="2231136"/>
+            <a:ext cx="3566160" cy="960120"/>
           </a:xfrm>
           <a:prstGeom prst="rect">
             <a:avLst/>
@@ -6536,13 +6536,85 @@
           <a:p>
             <a:pPr algn="l"/>
             <a:r>
-              <a:rPr sz="900" b="0">
+              <a:rPr sz="720" b="0">
                 <a:solidFill>
                   <a:srgbClr val="0F172A"/>
                 </a:solidFill>
                 <a:latin typeface="Aptos"/>
               </a:rPr>
-              <a:t>Cirrascale Qualcomm Cloud AI running DeepSeek-R1 (for reasoning traces) and Llama-3.1 (for fast edge inference).</a:t>
+              <a:t>Qualcomm Cloud AI (DeepSeek-R1-70B) via 6 Strict Rules:</a:t>
+            </a:r>
+          </a:p>
+          <a:p>
+            <a:pPr algn="l"/>
+            <a:r>
+              <a:rPr sz="720" b="0">
+                <a:solidFill>
+                  <a:srgbClr val="0F172A"/>
+                </a:solidFill>
+                <a:latin typeface="Aptos"/>
+              </a:rPr>
+              <a:t>1. Strict Accuracy: Null if missing, never guess dates</a:t>
+            </a:r>
+          </a:p>
+          <a:p>
+            <a:pPr algn="l"/>
+            <a:r>
+              <a:rPr sz="720" b="0">
+                <a:solidFill>
+                  <a:srgbClr val="0F172A"/>
+                </a:solidFill>
+                <a:latin typeface="Aptos"/>
+              </a:rPr>
+              <a:t>2. Confirmed vs Tentative: Separate proposals &amp; decisions</a:t>
+            </a:r>
+          </a:p>
+          <a:p>
+            <a:pPr algn="l"/>
+            <a:r>
+              <a:rPr sz="720" b="0">
+                <a:solidFill>
+                  <a:srgbClr val="0F172A"/>
+                </a:solidFill>
+                <a:latin typeface="Aptos"/>
+              </a:rPr>
+              <a:t>3. Vague Commitments: Flag 'soon'/'next week' with alerts</a:t>
+            </a:r>
+          </a:p>
+          <a:p>
+            <a:pPr algn="l"/>
+            <a:r>
+              <a:rPr sz="720" b="0">
+                <a:solidFill>
+                  <a:srgbClr val="0F172A"/>
+                </a:solidFill>
+                <a:latin typeface="Aptos"/>
+              </a:rPr>
+              <a:t>4. Verbatim Citations: Exact quote required for all items</a:t>
+            </a:r>
+          </a:p>
+          <a:p>
+            <a:pPr algn="l"/>
+            <a:r>
+              <a:rPr sz="720" b="0">
+                <a:solidFill>
+                  <a:srgbClr val="0F172A"/>
+                </a:solidFill>
+                <a:latin typeface="Aptos"/>
+              </a:rPr>
+              <a:t>5. Confidence Scoring: 0.0-1.0 indicative certainty signal</a:t>
+            </a:r>
+          </a:p>
+          <a:p>
+            <a:pPr algn="l"/>
+            <a:r>
+              <a:rPr sz="720" b="0">
+                <a:solidFill>
+                  <a:srgbClr val="0F172A"/>
+                </a:solidFill>
+                <a:latin typeface="Aptos"/>
+              </a:rPr>
+              <a:t>6. Reasoning Conciseness: &lt;50 words (slashes latency to 25s)</a:t>
             </a:r>
           </a:p>
         </p:txBody>
@@ -6660,13 +6732,49 @@
           <a:p>
             <a:pPr algn="l"/>
             <a:r>
-              <a:rPr sz="850" b="0">
+              <a:rPr sz="800" b="0">
                 <a:solidFill>
                   <a:srgbClr val="0F172A"/>
                 </a:solidFill>
                 <a:latin typeface="Aptos"/>
               </a:rPr>
-              <a:t>Verbatim citations enforced for all tasks/decisions; reasoning constrained to &lt;50 words (slashing latency to 25s); Pydantic type validation; 30 unit tests.</a:t>
+              <a:t>Quality &amp; Grounding Enforcement:</a:t>
+            </a:r>
+          </a:p>
+          <a:p>
+            <a:pPr algn="l"/>
+            <a:r>
+              <a:rPr sz="800" b="0">
+                <a:solidFill>
+                  <a:srgbClr val="0F172A"/>
+                </a:solidFill>
+                <a:latin typeface="Aptos"/>
+              </a:rPr>
+              <a:t>• Verbatim citations enforced for all tasks/decisions.</a:t>
+            </a:r>
+          </a:p>
+          <a:p>
+            <a:pPr algn="l"/>
+            <a:r>
+              <a:rPr sz="800" b="0">
+                <a:solidFill>
+                  <a:srgbClr val="0F172A"/>
+                </a:solidFill>
+                <a:latin typeface="Aptos"/>
+              </a:rPr>
+              <a:t>• Deterministic null-handling: zero invented owners or dates.</a:t>
+            </a:r>
+          </a:p>
+          <a:p>
+            <a:pPr algn="l"/>
+            <a:r>
+              <a:rPr sz="800" b="0">
+                <a:solidFill>
+                  <a:srgbClr val="0F172A"/>
+                </a:solidFill>
+                <a:latin typeface="Aptos"/>
+              </a:rPr>
+              <a:t>• Pydantic v2 schemas + 31 Pytest automated tests (100% pass).</a:t>
             </a:r>
           </a:p>
         </p:txBody>
@@ -7480,13 +7588,13 @@
           <a:p>
             <a:pPr algn="l"/>
             <a:r>
-              <a:rPr sz="850" b="0">
+              <a:rPr sz="800" b="0">
                 <a:solidFill>
                   <a:srgbClr val="0F172A"/>
                 </a:solidFill>
                 <a:latin typeface="Aptos"/>
               </a:rPr>
-              <a:t>Live Audio &amp; On-Device NPU Transcription: Whisper model integration running locally on Snapdragon X Elite NPU hardware.</a:t>
+              <a:t>Google Meet &amp; MS Teams Pipeline: Zero-touch ingestion via Microsoft Graph &amp; Google Workspace APIs, plus local Whisper on Snapdragon X Elite NPU.</a:t>
             </a:r>
           </a:p>
         </p:txBody>

</xml_diff>